<commit_message>
Add corporate PPT template workflow
</commit_message>
<xml_diff>
--- a/data/template_16_9.pptx
+++ b/data/template_16_9.pptx
@@ -4,7 +4,13 @@
   <p:sldMasterIdLst>
     <p:sldMasterId id="2147483648" r:id="rId1"/>
   </p:sldMasterIdLst>
-  <p:sldSz cx="12191695" cy="6858000" type="screen4x3"/>
+  <p:notesMasterIdLst>
+    <p:notesMasterId r:id="rId3"/>
+  </p:notesMasterIdLst>
+  <p:sldIdLst>
+    <p:sldId id="256" r:id="rId2"/>
+  </p:sldIdLst>
+  <p:sldSz cx="12192000" cy="6858000"/>
   <p:notesSz cx="6858000" cy="9144000"/>
   <p:defaultTextStyle>
     <a:defPPr>
@@ -101,7 +107,478 @@
       </a:defRPr>
     </a:lvl9pPr>
   </p:defaultTextStyle>
+  <p:extLst>
+    <p:ext uri="{EFAFB233-063F-42B5-8137-9DF3F51BA10A}">
+      <p15:sldGuideLst xmlns:p15="http://schemas.microsoft.com/office/powerpoint/2012/main">
+        <p15:guide id="1" orient="horz" pos="2160">
+          <p15:clr>
+            <a:srgbClr val="A4A3A4"/>
+          </p15:clr>
+        </p15:guide>
+        <p15:guide id="2" pos="2880">
+          <p15:clr>
+            <a:srgbClr val="A4A3A4"/>
+          </p15:clr>
+        </p15:guide>
+      </p15:sldGuideLst>
+    </p:ext>
+  </p:extLst>
 </p:presentation>
+</file>
+
+<file path=ppt/notesMasters/notesMaster1.xml><?xml version="1.0" encoding="utf-8"?>
+<p:notesMaster xmlns:a="http://schemas.openxmlformats.org/drawingml/2006/main" xmlns:r="http://schemas.openxmlformats.org/officeDocument/2006/relationships" xmlns:p="http://schemas.openxmlformats.org/presentationml/2006/main">
+  <p:cSld>
+    <p:bg>
+      <p:bgRef idx="1001">
+        <a:schemeClr val="bg1"/>
+      </p:bgRef>
+    </p:bg>
+    <p:spTree>
+      <p:nvGrpSpPr>
+        <p:cNvPr id="1" name=""/>
+        <p:cNvGrpSpPr/>
+        <p:nvPr/>
+      </p:nvGrpSpPr>
+      <p:grpSpPr>
+        <a:xfrm>
+          <a:off x="0" y="0"/>
+          <a:ext cx="0" cy="0"/>
+          <a:chOff x="0" y="0"/>
+          <a:chExt cx="0" cy="0"/>
+        </a:xfrm>
+      </p:grpSpPr>
+      <p:sp>
+        <p:nvSpPr>
+          <p:cNvPr id="2" name="머리글 개체 틀 1"/>
+          <p:cNvSpPr>
+            <a:spLocks noGrp="1"/>
+          </p:cNvSpPr>
+          <p:nvPr>
+            <p:ph type="hdr" sz="quarter"/>
+          </p:nvPr>
+        </p:nvSpPr>
+        <p:spPr>
+          <a:xfrm>
+            <a:off x="0" y="0"/>
+            <a:ext cx="2971800" cy="458788"/>
+          </a:xfrm>
+          <a:prstGeom prst="rect">
+            <a:avLst/>
+          </a:prstGeom>
+        </p:spPr>
+        <p:txBody>
+          <a:bodyPr vert="horz" lIns="91440" tIns="45720" rIns="91440" bIns="45720" rtlCol="0"/>
+          <a:lstStyle>
+            <a:lvl1pPr algn="l">
+              <a:defRPr sz="1200"/>
+            </a:lvl1pPr>
+          </a:lstStyle>
+          <a:p>
+            <a:endParaRPr lang="ko-KR" altLang="en-US"/>
+          </a:p>
+        </p:txBody>
+      </p:sp>
+      <p:sp>
+        <p:nvSpPr>
+          <p:cNvPr id="3" name="날짜 개체 틀 2"/>
+          <p:cNvSpPr>
+            <a:spLocks noGrp="1"/>
+          </p:cNvSpPr>
+          <p:nvPr>
+            <p:ph type="dt" idx="1"/>
+          </p:nvPr>
+        </p:nvSpPr>
+        <p:spPr>
+          <a:xfrm>
+            <a:off x="3884613" y="0"/>
+            <a:ext cx="2971800" cy="458788"/>
+          </a:xfrm>
+          <a:prstGeom prst="rect">
+            <a:avLst/>
+          </a:prstGeom>
+        </p:spPr>
+        <p:txBody>
+          <a:bodyPr vert="horz" lIns="91440" tIns="45720" rIns="91440" bIns="45720" rtlCol="0"/>
+          <a:lstStyle>
+            <a:lvl1pPr algn="r">
+              <a:defRPr sz="1200"/>
+            </a:lvl1pPr>
+          </a:lstStyle>
+          <a:p>
+            <a:fld id="{AC6DE22D-F941-4156-A001-D20DD8FDA104}" type="datetimeFigureOut">
+              <a:rPr lang="ko-KR" altLang="en-US" smtClean="0"/>
+              <a:t>2026-07-29</a:t>
+            </a:fld>
+            <a:endParaRPr lang="ko-KR" altLang="en-US"/>
+          </a:p>
+        </p:txBody>
+      </p:sp>
+      <p:sp>
+        <p:nvSpPr>
+          <p:cNvPr id="4" name="슬라이드 이미지 개체 틀 3"/>
+          <p:cNvSpPr>
+            <a:spLocks noGrp="1" noRot="1" noChangeAspect="1"/>
+          </p:cNvSpPr>
+          <p:nvPr>
+            <p:ph type="sldImg" idx="2"/>
+          </p:nvPr>
+        </p:nvSpPr>
+        <p:spPr>
+          <a:xfrm>
+            <a:off x="685800" y="1143000"/>
+            <a:ext cx="5486400" cy="3086100"/>
+          </a:xfrm>
+          <a:prstGeom prst="rect">
+            <a:avLst/>
+          </a:prstGeom>
+          <a:noFill/>
+          <a:ln w="12700">
+            <a:solidFill>
+              <a:prstClr val="black"/>
+            </a:solidFill>
+          </a:ln>
+        </p:spPr>
+        <p:txBody>
+          <a:bodyPr vert="horz" lIns="91440" tIns="45720" rIns="91440" bIns="45720" rtlCol="0" anchor="ctr"/>
+          <a:lstStyle/>
+          <a:p>
+            <a:endParaRPr lang="ko-KR" altLang="en-US"/>
+          </a:p>
+        </p:txBody>
+      </p:sp>
+      <p:sp>
+        <p:nvSpPr>
+          <p:cNvPr id="5" name="슬라이드 노트 개체 틀 4"/>
+          <p:cNvSpPr>
+            <a:spLocks noGrp="1"/>
+          </p:cNvSpPr>
+          <p:nvPr>
+            <p:ph type="body" sz="quarter" idx="3"/>
+          </p:nvPr>
+        </p:nvSpPr>
+        <p:spPr>
+          <a:xfrm>
+            <a:off x="685800" y="4400550"/>
+            <a:ext cx="5486400" cy="3600450"/>
+          </a:xfrm>
+          <a:prstGeom prst="rect">
+            <a:avLst/>
+          </a:prstGeom>
+        </p:spPr>
+        <p:txBody>
+          <a:bodyPr vert="horz" lIns="91440" tIns="45720" rIns="91440" bIns="45720" rtlCol="0"/>
+          <a:lstStyle/>
+          <a:p>
+            <a:pPr lvl="0"/>
+            <a:r>
+              <a:rPr lang="ko-KR" altLang="en-US"/>
+              <a:t>마스터 텍스트 스타일을 편집하려면 클릭</a:t>
+            </a:r>
+          </a:p>
+          <a:p>
+            <a:pPr lvl="1"/>
+            <a:r>
+              <a:rPr lang="ko-KR" altLang="en-US"/>
+              <a:t>두 번째 수준</a:t>
+            </a:r>
+          </a:p>
+          <a:p>
+            <a:pPr lvl="2"/>
+            <a:r>
+              <a:rPr lang="ko-KR" altLang="en-US"/>
+              <a:t>세 번째 수준</a:t>
+            </a:r>
+          </a:p>
+          <a:p>
+            <a:pPr lvl="3"/>
+            <a:r>
+              <a:rPr lang="ko-KR" altLang="en-US"/>
+              <a:t>네 번째 수준</a:t>
+            </a:r>
+          </a:p>
+          <a:p>
+            <a:pPr lvl="4"/>
+            <a:r>
+              <a:rPr lang="ko-KR" altLang="en-US"/>
+              <a:t>다섯 번째 수준</a:t>
+            </a:r>
+          </a:p>
+        </p:txBody>
+      </p:sp>
+      <p:sp>
+        <p:nvSpPr>
+          <p:cNvPr id="6" name="바닥글 개체 틀 5"/>
+          <p:cNvSpPr>
+            <a:spLocks noGrp="1"/>
+          </p:cNvSpPr>
+          <p:nvPr>
+            <p:ph type="ftr" sz="quarter" idx="4"/>
+          </p:nvPr>
+        </p:nvSpPr>
+        <p:spPr>
+          <a:xfrm>
+            <a:off x="0" y="8685213"/>
+            <a:ext cx="2971800" cy="458787"/>
+          </a:xfrm>
+          <a:prstGeom prst="rect">
+            <a:avLst/>
+          </a:prstGeom>
+        </p:spPr>
+        <p:txBody>
+          <a:bodyPr vert="horz" lIns="91440" tIns="45720" rIns="91440" bIns="45720" rtlCol="0" anchor="b"/>
+          <a:lstStyle>
+            <a:lvl1pPr algn="l">
+              <a:defRPr sz="1200"/>
+            </a:lvl1pPr>
+          </a:lstStyle>
+          <a:p>
+            <a:endParaRPr lang="ko-KR" altLang="en-US"/>
+          </a:p>
+        </p:txBody>
+      </p:sp>
+      <p:sp>
+        <p:nvSpPr>
+          <p:cNvPr id="7" name="슬라이드 번호 개체 틀 6"/>
+          <p:cNvSpPr>
+            <a:spLocks noGrp="1"/>
+          </p:cNvSpPr>
+          <p:nvPr>
+            <p:ph type="sldNum" sz="quarter" idx="5"/>
+          </p:nvPr>
+        </p:nvSpPr>
+        <p:spPr>
+          <a:xfrm>
+            <a:off x="3884613" y="8685213"/>
+            <a:ext cx="2971800" cy="458787"/>
+          </a:xfrm>
+          <a:prstGeom prst="rect">
+            <a:avLst/>
+          </a:prstGeom>
+        </p:spPr>
+        <p:txBody>
+          <a:bodyPr vert="horz" lIns="91440" tIns="45720" rIns="91440" bIns="45720" rtlCol="0" anchor="b"/>
+          <a:lstStyle>
+            <a:lvl1pPr algn="r">
+              <a:defRPr sz="1200"/>
+            </a:lvl1pPr>
+          </a:lstStyle>
+          <a:p>
+            <a:fld id="{C2425DC6-D927-40BA-AABB-29792EC49B12}" type="slidenum">
+              <a:rPr lang="ko-KR" altLang="en-US" smtClean="0"/>
+              <a:t>‹#›</a:t>
+            </a:fld>
+            <a:endParaRPr lang="ko-KR" altLang="en-US"/>
+          </a:p>
+        </p:txBody>
+      </p:sp>
+    </p:spTree>
+    <p:extLst>
+      <p:ext uri="{BB962C8B-B14F-4D97-AF65-F5344CB8AC3E}">
+        <p14:creationId xmlns:p14="http://schemas.microsoft.com/office/powerpoint/2010/main" val="3366342792"/>
+      </p:ext>
+    </p:extLst>
+  </p:cSld>
+  <p:clrMap bg1="lt1" tx1="dk1" bg2="lt2" tx2="dk2" accent1="accent1" accent2="accent2" accent3="accent3" accent4="accent4" accent5="accent5" accent6="accent6" hlink="hlink" folHlink="folHlink"/>
+  <p:notesStyle>
+    <a:lvl1pPr marL="0" algn="l" defTabSz="914400" rtl="0" eaLnBrk="1" latinLnBrk="1" hangingPunct="1">
+      <a:defRPr sz="1200" kern="1200">
+        <a:solidFill>
+          <a:schemeClr val="tx1"/>
+        </a:solidFill>
+        <a:latin typeface="+mn-lt"/>
+        <a:ea typeface="+mn-ea"/>
+        <a:cs typeface="+mn-cs"/>
+      </a:defRPr>
+    </a:lvl1pPr>
+    <a:lvl2pPr marL="457200" algn="l" defTabSz="914400" rtl="0" eaLnBrk="1" latinLnBrk="1" hangingPunct="1">
+      <a:defRPr sz="1200" kern="1200">
+        <a:solidFill>
+          <a:schemeClr val="tx1"/>
+        </a:solidFill>
+        <a:latin typeface="+mn-lt"/>
+        <a:ea typeface="+mn-ea"/>
+        <a:cs typeface="+mn-cs"/>
+      </a:defRPr>
+    </a:lvl2pPr>
+    <a:lvl3pPr marL="914400" algn="l" defTabSz="914400" rtl="0" eaLnBrk="1" latinLnBrk="1" hangingPunct="1">
+      <a:defRPr sz="1200" kern="1200">
+        <a:solidFill>
+          <a:schemeClr val="tx1"/>
+        </a:solidFill>
+        <a:latin typeface="+mn-lt"/>
+        <a:ea typeface="+mn-ea"/>
+        <a:cs typeface="+mn-cs"/>
+      </a:defRPr>
+    </a:lvl3pPr>
+    <a:lvl4pPr marL="1371600" algn="l" defTabSz="914400" rtl="0" eaLnBrk="1" latinLnBrk="1" hangingPunct="1">
+      <a:defRPr sz="1200" kern="1200">
+        <a:solidFill>
+          <a:schemeClr val="tx1"/>
+        </a:solidFill>
+        <a:latin typeface="+mn-lt"/>
+        <a:ea typeface="+mn-ea"/>
+        <a:cs typeface="+mn-cs"/>
+      </a:defRPr>
+    </a:lvl4pPr>
+    <a:lvl5pPr marL="1828800" algn="l" defTabSz="914400" rtl="0" eaLnBrk="1" latinLnBrk="1" hangingPunct="1">
+      <a:defRPr sz="1200" kern="1200">
+        <a:solidFill>
+          <a:schemeClr val="tx1"/>
+        </a:solidFill>
+        <a:latin typeface="+mn-lt"/>
+        <a:ea typeface="+mn-ea"/>
+        <a:cs typeface="+mn-cs"/>
+      </a:defRPr>
+    </a:lvl5pPr>
+    <a:lvl6pPr marL="2286000" algn="l" defTabSz="914400" rtl="0" eaLnBrk="1" latinLnBrk="1" hangingPunct="1">
+      <a:defRPr sz="1200" kern="1200">
+        <a:solidFill>
+          <a:schemeClr val="tx1"/>
+        </a:solidFill>
+        <a:latin typeface="+mn-lt"/>
+        <a:ea typeface="+mn-ea"/>
+        <a:cs typeface="+mn-cs"/>
+      </a:defRPr>
+    </a:lvl6pPr>
+    <a:lvl7pPr marL="2743200" algn="l" defTabSz="914400" rtl="0" eaLnBrk="1" latinLnBrk="1" hangingPunct="1">
+      <a:defRPr sz="1200" kern="1200">
+        <a:solidFill>
+          <a:schemeClr val="tx1"/>
+        </a:solidFill>
+        <a:latin typeface="+mn-lt"/>
+        <a:ea typeface="+mn-ea"/>
+        <a:cs typeface="+mn-cs"/>
+      </a:defRPr>
+    </a:lvl7pPr>
+    <a:lvl8pPr marL="3200400" algn="l" defTabSz="914400" rtl="0" eaLnBrk="1" latinLnBrk="1" hangingPunct="1">
+      <a:defRPr sz="1200" kern="1200">
+        <a:solidFill>
+          <a:schemeClr val="tx1"/>
+        </a:solidFill>
+        <a:latin typeface="+mn-lt"/>
+        <a:ea typeface="+mn-ea"/>
+        <a:cs typeface="+mn-cs"/>
+      </a:defRPr>
+    </a:lvl8pPr>
+    <a:lvl9pPr marL="3657600" algn="l" defTabSz="914400" rtl="0" eaLnBrk="1" latinLnBrk="1" hangingPunct="1">
+      <a:defRPr sz="1200" kern="1200">
+        <a:solidFill>
+          <a:schemeClr val="tx1"/>
+        </a:solidFill>
+        <a:latin typeface="+mn-lt"/>
+        <a:ea typeface="+mn-ea"/>
+        <a:cs typeface="+mn-cs"/>
+      </a:defRPr>
+    </a:lvl9pPr>
+  </p:notesStyle>
+</p:notesMaster>
+</file>
+
+<file path=ppt/notesSlides/notesSlide1.xml><?xml version="1.0" encoding="utf-8"?>
+<p:notes xmlns:a="http://schemas.openxmlformats.org/drawingml/2006/main" xmlns:r="http://schemas.openxmlformats.org/officeDocument/2006/relationships" xmlns:p="http://schemas.openxmlformats.org/presentationml/2006/main">
+  <p:cSld>
+    <p:spTree>
+      <p:nvGrpSpPr>
+        <p:cNvPr id="1" name=""/>
+        <p:cNvGrpSpPr/>
+        <p:nvPr/>
+      </p:nvGrpSpPr>
+      <p:grpSpPr>
+        <a:xfrm>
+          <a:off x="0" y="0"/>
+          <a:ext cx="0" cy="0"/>
+          <a:chOff x="0" y="0"/>
+          <a:chExt cx="0" cy="0"/>
+        </a:xfrm>
+      </p:grpSpPr>
+      <p:sp>
+        <p:nvSpPr>
+          <p:cNvPr id="2" name="슬라이드 이미지 개체 틀 1"/>
+          <p:cNvSpPr>
+            <a:spLocks noGrp="1" noRot="1" noChangeAspect="1"/>
+          </p:cNvSpPr>
+          <p:nvPr>
+            <p:ph type="sldImg"/>
+          </p:nvPr>
+        </p:nvSpPr>
+        <p:spPr/>
+      </p:sp>
+      <p:sp>
+        <p:nvSpPr>
+          <p:cNvPr id="3" name="슬라이드 노트 개체 틀 2"/>
+          <p:cNvSpPr>
+            <a:spLocks noGrp="1"/>
+          </p:cNvSpPr>
+          <p:nvPr>
+            <p:ph type="body" idx="1"/>
+          </p:nvPr>
+        </p:nvSpPr>
+        <p:spPr/>
+        <p:txBody>
+          <a:bodyPr/>
+          <a:lstStyle/>
+          <a:p>
+            <a:r>
+              <a:rPr lang="en-US" altLang="ko-KR"/>
+              <a:t>[Sources]</a:t>
+            </a:r>
+          </a:p>
+          <a:p>
+            <a:r>
+              <a:rPr lang="en-US" altLang="ko-KR"/>
+              <a:t>- https://news.samsung.com/es/imagenes-logotipo-samsung (Samsung official newsroom wordmark asset)</a:t>
+            </a:r>
+          </a:p>
+          <a:p>
+            <a:r>
+              <a:rPr lang="en-US" altLang="ko-KR"/>
+              <a:t>- Corporate layout measurements supplied by the user</a:t>
+            </a:r>
+          </a:p>
+          <a:p>
+            <a:r>
+              <a:rPr lang="en-US" altLang="ko-KR"/>
+              <a:t>[/Sources]</a:t>
+            </a:r>
+            <a:endParaRPr lang="ko-KR" altLang="en-US"/>
+          </a:p>
+        </p:txBody>
+      </p:sp>
+      <p:sp>
+        <p:nvSpPr>
+          <p:cNvPr id="4" name="슬라이드 번호 개체 틀 3"/>
+          <p:cNvSpPr>
+            <a:spLocks noGrp="1"/>
+          </p:cNvSpPr>
+          <p:nvPr>
+            <p:ph type="sldNum" sz="quarter" idx="5"/>
+          </p:nvPr>
+        </p:nvSpPr>
+        <p:spPr/>
+        <p:txBody>
+          <a:bodyPr/>
+          <a:lstStyle/>
+          <a:p>
+            <a:fld id="{C2425DC6-D927-40BA-AABB-29792EC49B12}" type="slidenum">
+              <a:rPr lang="ko-KR" altLang="en-US" smtClean="0"/>
+              <a:t>1</a:t>
+            </a:fld>
+            <a:endParaRPr lang="ko-KR" altLang="en-US"/>
+          </a:p>
+        </p:txBody>
+      </p:sp>
+    </p:spTree>
+    <p:extLst>
+      <p:ext uri="{BB962C8B-B14F-4D97-AF65-F5344CB8AC3E}">
+        <p14:creationId xmlns:p14="http://schemas.microsoft.com/office/powerpoint/2010/main" val="3532351417"/>
+      </p:ext>
+    </p:extLst>
+  </p:cSld>
+  <p:clrMapOvr>
+    <a:masterClrMapping/>
+  </p:clrMapOvr>
+</p:notes>
 </file>
 
 <file path=ppt/slideLayouts/slideLayout1.xml><?xml version="1.0" encoding="utf-8"?>
@@ -142,10 +619,9 @@
           <a:lstStyle/>
           <a:p>
             <a:r>
-              <a:rPr lang="en-US" smtClean="0"/>
+              <a:rPr lang="en-US"/>
               <a:t>Click to edit Master title style</a:t>
             </a:r>
-            <a:endParaRPr lang="en-US"/>
           </a:p>
         </p:txBody>
       </p:sp>
@@ -261,10 +737,9 @@
           </a:lstStyle>
           <a:p>
             <a:r>
-              <a:rPr lang="en-US" smtClean="0"/>
+              <a:rPr lang="en-US"/>
               <a:t>Click to edit Master subtitle style</a:t>
             </a:r>
-            <a:endParaRPr lang="en-US"/>
           </a:p>
         </p:txBody>
       </p:sp>
@@ -285,7 +760,7 @@
           <a:p>
             <a:fld id="{5BCAD085-E8A6-8845-BD4E-CB4CCA059FC4}" type="datetimeFigureOut">
               <a:rPr lang="en-US" smtClean="0"/>
-              <a:t>1/27/13</a:t>
+              <a:t>7/29/2026</a:t>
             </a:fld>
             <a:endParaRPr lang="en-US"/>
           </a:p>
@@ -379,10 +854,9 @@
           <a:lstStyle/>
           <a:p>
             <a:r>
-              <a:rPr lang="en-US" smtClean="0"/>
+              <a:rPr lang="en-US"/>
               <a:t>Click to edit Master title style</a:t>
             </a:r>
-            <a:endParaRPr lang="en-US"/>
           </a:p>
         </p:txBody>
       </p:sp>
@@ -403,38 +877,37 @@
           <a:p>
             <a:pPr lvl="0"/>
             <a:r>
-              <a:rPr lang="en-US" smtClean="0"/>
+              <a:rPr lang="en-US"/>
               <a:t>Click to edit Master text styles</a:t>
             </a:r>
           </a:p>
           <a:p>
             <a:pPr lvl="1"/>
             <a:r>
-              <a:rPr lang="en-US" smtClean="0"/>
+              <a:rPr lang="en-US"/>
               <a:t>Second level</a:t>
             </a:r>
           </a:p>
           <a:p>
             <a:pPr lvl="2"/>
             <a:r>
-              <a:rPr lang="en-US" smtClean="0"/>
+              <a:rPr lang="en-US"/>
               <a:t>Third level</a:t>
             </a:r>
           </a:p>
           <a:p>
             <a:pPr lvl="3"/>
             <a:r>
-              <a:rPr lang="en-US" smtClean="0"/>
+              <a:rPr lang="en-US"/>
               <a:t>Fourth level</a:t>
             </a:r>
           </a:p>
           <a:p>
             <a:pPr lvl="4"/>
             <a:r>
-              <a:rPr lang="en-US" smtClean="0"/>
+              <a:rPr lang="en-US"/>
               <a:t>Fifth level</a:t>
             </a:r>
-            <a:endParaRPr lang="en-US"/>
           </a:p>
         </p:txBody>
       </p:sp>
@@ -455,7 +928,7 @@
           <a:p>
             <a:fld id="{5BCAD085-E8A6-8845-BD4E-CB4CCA059FC4}" type="datetimeFigureOut">
               <a:rPr lang="en-US" smtClean="0"/>
-              <a:t>1/27/13</a:t>
+              <a:t>7/29/2026</a:t>
             </a:fld>
             <a:endParaRPr lang="en-US"/>
           </a:p>
@@ -554,10 +1027,9 @@
           <a:lstStyle/>
           <a:p>
             <a:r>
-              <a:rPr lang="en-US" smtClean="0"/>
+              <a:rPr lang="en-US"/>
               <a:t>Click to edit Master title style</a:t>
             </a:r>
-            <a:endParaRPr lang="en-US"/>
           </a:p>
         </p:txBody>
       </p:sp>
@@ -583,38 +1055,37 @@
           <a:p>
             <a:pPr lvl="0"/>
             <a:r>
-              <a:rPr lang="en-US" smtClean="0"/>
+              <a:rPr lang="en-US"/>
               <a:t>Click to edit Master text styles</a:t>
             </a:r>
           </a:p>
           <a:p>
             <a:pPr lvl="1"/>
             <a:r>
-              <a:rPr lang="en-US" smtClean="0"/>
+              <a:rPr lang="en-US"/>
               <a:t>Second level</a:t>
             </a:r>
           </a:p>
           <a:p>
             <a:pPr lvl="2"/>
             <a:r>
-              <a:rPr lang="en-US" smtClean="0"/>
+              <a:rPr lang="en-US"/>
               <a:t>Third level</a:t>
             </a:r>
           </a:p>
           <a:p>
             <a:pPr lvl="3"/>
             <a:r>
-              <a:rPr lang="en-US" smtClean="0"/>
+              <a:rPr lang="en-US"/>
               <a:t>Fourth level</a:t>
             </a:r>
           </a:p>
           <a:p>
             <a:pPr lvl="4"/>
             <a:r>
-              <a:rPr lang="en-US" smtClean="0"/>
+              <a:rPr lang="en-US"/>
               <a:t>Fifth level</a:t>
             </a:r>
-            <a:endParaRPr lang="en-US"/>
           </a:p>
         </p:txBody>
       </p:sp>
@@ -635,7 +1106,7 @@
           <a:p>
             <a:fld id="{5BCAD085-E8A6-8845-BD4E-CB4CCA059FC4}" type="datetimeFigureOut">
               <a:rPr lang="en-US" smtClean="0"/>
-              <a:t>1/27/13</a:t>
+              <a:t>7/29/2026</a:t>
             </a:fld>
             <a:endParaRPr lang="en-US"/>
           </a:p>
@@ -715,22 +1186,39 @@
       </p:grpSpPr>
       <p:sp>
         <p:nvSpPr>
-          <p:cNvPr id="2" name="Title 1"/>
-          <p:cNvSpPr>
-            <a:spLocks noGrp="1"/>
-          </p:cNvSpPr>
-          <p:nvPr>
-            <p:ph type="title"/>
-          </p:nvPr>
-        </p:nvSpPr>
-        <p:spPr/>
-        <p:txBody>
-          <a:bodyPr/>
-          <a:lstStyle/>
-          <a:p>
-            <a:r>
-              <a:rPr lang="en-US" smtClean="0"/>
-              <a:t>Click to edit Master title style</a:t>
+          <p:cNvPr id="2" name="DRB_Title_Placeholder"/>
+          <p:cNvSpPr>
+            <a:spLocks noGrp="1"/>
+          </p:cNvSpPr>
+          <p:nvPr>
+            <p:ph type="title" hasCustomPrompt="1"/>
+          </p:nvPr>
+        </p:nvSpPr>
+        <p:spPr>
+          <a:xfrm>
+            <a:off x="270000" y="342000"/>
+            <a:ext cx="10302000" cy="486000"/>
+          </a:xfrm>
+        </p:spPr>
+        <p:txBody>
+          <a:bodyPr wrap="none" lIns="0" tIns="0" rIns="0" bIns="0" anchor="ctr">
+            <a:noAutofit/>
+          </a:bodyPr>
+          <a:lstStyle>
+            <a:lvl1pPr algn="l">
+              <a:defRPr sz="2800" b="1">
+                <a:solidFill>
+                  <a:srgbClr val="111111"/>
+                </a:solidFill>
+                <a:latin typeface="맑은 고딕" panose="020B0503020000020004" pitchFamily="50" charset="-127"/>
+                <a:ea typeface="맑은 고딕" panose="020B0503020000020004" pitchFamily="50" charset="-127"/>
+              </a:defRPr>
+            </a:lvl1pPr>
+          </a:lstStyle>
+          <a:p>
+            <a:r>
+              <a:rPr lang="ko-KR" altLang="en-US"/>
+              <a:t>슬라이드 제목</a:t>
             </a:r>
             <a:endParaRPr lang="en-US"/>
           </a:p>
@@ -738,51 +1226,42 @@
       </p:sp>
       <p:sp>
         <p:nvSpPr>
-          <p:cNvPr id="3" name="Content Placeholder 2"/>
-          <p:cNvSpPr>
-            <a:spLocks noGrp="1"/>
-          </p:cNvSpPr>
-          <p:nvPr>
-            <p:ph idx="1"/>
-          </p:nvPr>
-        </p:nvSpPr>
-        <p:spPr/>
-        <p:txBody>
-          <a:bodyPr/>
-          <a:lstStyle/>
+          <p:cNvPr id="3" name="DRB_Body_Placeholder"/>
+          <p:cNvSpPr>
+            <a:spLocks noGrp="1"/>
+          </p:cNvSpPr>
+          <p:nvPr>
+            <p:ph idx="1" hasCustomPrompt="1"/>
+          </p:nvPr>
+        </p:nvSpPr>
+        <p:spPr>
+          <a:xfrm>
+            <a:off x="270000" y="943200"/>
+            <a:ext cx="11520000" cy="583200"/>
+          </a:xfrm>
+        </p:spPr>
+        <p:txBody>
+          <a:bodyPr wrap="none" lIns="0" tIns="0" rIns="0" bIns="0" anchor="ctr">
+            <a:noAutofit/>
+          </a:bodyPr>
+          <a:lstStyle>
+            <a:lvl1pPr marL="0" indent="0" algn="l">
+              <a:buFontTx/>
+              <a:buNone/>
+              <a:defRPr sz="1300" b="1">
+                <a:solidFill>
+                  <a:srgbClr val="333333"/>
+                </a:solidFill>
+                <a:latin typeface="맑은 고딕" panose="020B0503020000020004" pitchFamily="50" charset="-127"/>
+                <a:ea typeface="맑은 고딕" panose="020B0503020000020004" pitchFamily="50" charset="-127"/>
+              </a:defRPr>
+            </a:lvl1pPr>
+          </a:lstStyle>
           <a:p>
             <a:pPr lvl="0"/>
             <a:r>
-              <a:rPr lang="en-US" smtClean="0"/>
-              <a:t>Click to edit Master text styles</a:t>
-            </a:r>
-          </a:p>
-          <a:p>
-            <a:pPr lvl="1"/>
-            <a:r>
-              <a:rPr lang="en-US" smtClean="0"/>
-              <a:t>Second level</a:t>
-            </a:r>
-          </a:p>
-          <a:p>
-            <a:pPr lvl="2"/>
-            <a:r>
-              <a:rPr lang="en-US" smtClean="0"/>
-              <a:t>Third level</a:t>
-            </a:r>
-          </a:p>
-          <a:p>
-            <a:pPr lvl="3"/>
-            <a:r>
-              <a:rPr lang="en-US" smtClean="0"/>
-              <a:t>Fourth level</a:t>
-            </a:r>
-          </a:p>
-          <a:p>
-            <a:pPr lvl="4"/>
-            <a:r>
-              <a:rPr lang="en-US" smtClean="0"/>
-              <a:t>Fifth level</a:t>
+              <a:rPr lang="ko-KR" altLang="en-US"/>
+              <a:t>■ 본문</a:t>
             </a:r>
             <a:endParaRPr lang="en-US"/>
           </a:p>
@@ -805,7 +1284,7 @@
           <a:p>
             <a:fld id="{5BCAD085-E8A6-8845-BD4E-CB4CCA059FC4}" type="datetimeFigureOut">
               <a:rPr lang="en-US" smtClean="0"/>
-              <a:t>1/27/13</a:t>
+              <a:t>7/29/2026</a:t>
             </a:fld>
             <a:endParaRPr lang="en-US"/>
           </a:p>
@@ -850,6 +1329,182 @@
               <a:t>‹#›</a:t>
             </a:fld>
             <a:endParaRPr lang="en-US"/>
+          </a:p>
+        </p:txBody>
+      </p:sp>
+      <p:cxnSp>
+        <p:nvCxnSpPr>
+          <p:cNvPr id="7" name="DRB_Divider">
+            <a:extLst>
+              <a:ext uri="{FF2B5EF4-FFF2-40B4-BE49-F238E27FC236}">
+                <a16:creationId xmlns:a16="http://schemas.microsoft.com/office/drawing/2014/main" id="{6D198FB5-2C2E-6433-70CD-E9732C4D68C8}"/>
+              </a:ext>
+            </a:extLst>
+          </p:cNvPr>
+          <p:cNvCxnSpPr/>
+          <p:nvPr userDrawn="1"/>
+        </p:nvCxnSpPr>
+        <p:spPr>
+          <a:xfrm>
+            <a:off x="336000" y="903600"/>
+            <a:ext cx="11520000" cy="0"/>
+          </a:xfrm>
+          <a:prstGeom prst="line">
+            <a:avLst/>
+          </a:prstGeom>
+          <a:ln w="6350">
+            <a:solidFill>
+              <a:srgbClr val="B7B7B7"/>
+            </a:solidFill>
+          </a:ln>
+          <a:effectLst/>
+          <a:extLst>
+            <a:ext uri="{AF507438-7753-43E0-B8FC-AC1667EBCBE1}">
+              <a14:hiddenEffects xmlns:a14="http://schemas.microsoft.com/office/drawing/2010/main">
+                <a:effectLst>
+                  <a:outerShdw blurRad="40000" dist="20000" dir="5400000" rotWithShape="0">
+                    <a:srgbClr val="000000">
+                      <a:alpha val="38000"/>
+                    </a:srgbClr>
+                  </a:outerShdw>
+                </a:effectLst>
+              </a14:hiddenEffects>
+            </a:ext>
+          </a:extLst>
+        </p:spPr>
+        <p:style>
+          <a:lnRef idx="2">
+            <a:schemeClr val="accent1"/>
+          </a:lnRef>
+          <a:fillRef idx="0">
+            <a:schemeClr val="accent1"/>
+          </a:fillRef>
+          <a:effectRef idx="1">
+            <a:schemeClr val="accent1"/>
+          </a:effectRef>
+          <a:fontRef idx="minor">
+            <a:schemeClr val="tx1"/>
+          </a:fontRef>
+        </p:style>
+      </p:cxnSp>
+      <p:pic>
+        <p:nvPicPr>
+          <p:cNvPr id="9" name="DRB_Samsung_Logo">
+            <a:extLst>
+              <a:ext uri="{FF2B5EF4-FFF2-40B4-BE49-F238E27FC236}">
+                <a16:creationId xmlns:a16="http://schemas.microsoft.com/office/drawing/2014/main" id="{E595D573-1678-7A0D-5560-1618FDE4C116}"/>
+              </a:ext>
+            </a:extLst>
+          </p:cNvPr>
+          <p:cNvPicPr>
+            <a:picLocks/>
+          </p:cNvPicPr>
+          <p:nvPr userDrawn="1"/>
+        </p:nvPicPr>
+        <p:blipFill>
+          <a:blip r:embed="rId2"/>
+          <a:stretch>
+            <a:fillRect/>
+          </a:stretch>
+        </p:blipFill>
+        <p:spPr>
+          <a:xfrm>
+            <a:off x="10716000" y="360000"/>
+            <a:ext cx="1162800" cy="198000"/>
+          </a:xfrm>
+          <a:prstGeom prst="rect">
+            <a:avLst/>
+          </a:prstGeom>
+        </p:spPr>
+      </p:pic>
+      <p:sp>
+        <p:nvSpPr>
+          <p:cNvPr id="10" name="DRB_Footer_Message">
+            <a:extLst>
+              <a:ext uri="{FF2B5EF4-FFF2-40B4-BE49-F238E27FC236}">
+                <a16:creationId xmlns:a16="http://schemas.microsoft.com/office/drawing/2014/main" id="{9E7B8FAD-DAA3-690C-7B7D-865BF8591144}"/>
+              </a:ext>
+            </a:extLst>
+          </p:cNvPr>
+          <p:cNvSpPr txBox="1"/>
+          <p:nvPr userDrawn="1"/>
+        </p:nvSpPr>
+        <p:spPr>
+          <a:xfrm>
+            <a:off x="439200" y="6462000"/>
+            <a:ext cx="2448000" cy="198000"/>
+          </a:xfrm>
+          <a:prstGeom prst="rect">
+            <a:avLst/>
+          </a:prstGeom>
+          <a:noFill/>
+        </p:spPr>
+        <p:txBody>
+          <a:bodyPr vert="horz" wrap="none" lIns="0" tIns="0" rIns="0" bIns="0" rtlCol="0" anchor="ctr">
+            <a:noAutofit/>
+          </a:bodyPr>
+          <a:lstStyle/>
+          <a:p>
+            <a:pPr algn="l"/>
+            <a:r>
+              <a:rPr lang="ko-KR" altLang="en-US" sz="1200" b="0">
+                <a:solidFill>
+                  <a:srgbClr val="A6A6A6"/>
+                </a:solidFill>
+                <a:latin typeface="맑은 고딕" panose="020B0503020000020004" pitchFamily="50" charset="-127"/>
+                <a:ea typeface="맑은 고딕" panose="020B0503020000020004" pitchFamily="50" charset="-127"/>
+              </a:rPr>
+              <a:t>함께 성장하는 행복한 메모리사업부</a:t>
+            </a:r>
+          </a:p>
+        </p:txBody>
+      </p:sp>
+      <p:sp>
+        <p:nvSpPr>
+          <p:cNvPr id="11" name="DRB_Confidential">
+            <a:extLst>
+              <a:ext uri="{FF2B5EF4-FFF2-40B4-BE49-F238E27FC236}">
+                <a16:creationId xmlns:a16="http://schemas.microsoft.com/office/drawing/2014/main" id="{9F399E75-B9CE-5940-1934-24EA33AB0E46}"/>
+              </a:ext>
+            </a:extLst>
+          </p:cNvPr>
+          <p:cNvSpPr txBox="1"/>
+          <p:nvPr userDrawn="1"/>
+        </p:nvSpPr>
+        <p:spPr>
+          <a:xfrm>
+            <a:off x="10842000" y="6422400"/>
+            <a:ext cx="1152000" cy="237600"/>
+          </a:xfrm>
+          <a:prstGeom prst="rect">
+            <a:avLst/>
+          </a:prstGeom>
+          <a:noFill/>
+        </p:spPr>
+        <p:txBody>
+          <a:bodyPr vert="horz" wrap="none" lIns="0" tIns="0" rIns="0" bIns="0" rtlCol="0" anchor="ctr">
+            <a:noAutofit/>
+          </a:bodyPr>
+          <a:lstStyle/>
+          <a:p>
+            <a:pPr algn="r"/>
+            <a:r>
+              <a:rPr lang="en-US" altLang="ko-KR" sz="1200" b="1">
+                <a:solidFill>
+                  <a:srgbClr val="E17D7D"/>
+                </a:solidFill>
+                <a:latin typeface="맑은 고딕" panose="020B0503020000020004" pitchFamily="50" charset="-127"/>
+                <a:ea typeface="맑은 고딕" panose="020B0503020000020004" pitchFamily="50" charset="-127"/>
+              </a:rPr>
+              <a:t>Confidential</a:t>
+            </a:r>
+            <a:endParaRPr lang="ko-KR" altLang="en-US" sz="1200" b="1">
+              <a:solidFill>
+                <a:srgbClr val="E17D7D"/>
+              </a:solidFill>
+              <a:latin typeface="맑은 고딕" panose="020B0503020000020004" pitchFamily="50" charset="-127"/>
+              <a:ea typeface="맑은 고딕" panose="020B0503020000020004" pitchFamily="50" charset="-127"/>
+            </a:endParaRPr>
           </a:p>
         </p:txBody>
       </p:sp>
@@ -908,10 +1563,9 @@
           </a:lstStyle>
           <a:p>
             <a:r>
-              <a:rPr lang="en-US" smtClean="0"/>
+              <a:rPr lang="en-US"/>
               <a:t>Click to edit Master title style</a:t>
             </a:r>
-            <a:endParaRPr lang="en-US"/>
           </a:p>
         </p:txBody>
       </p:sp>
@@ -1028,7 +1682,7 @@
           <a:p>
             <a:pPr lvl="0"/>
             <a:r>
-              <a:rPr lang="en-US" smtClean="0"/>
+              <a:rPr lang="en-US"/>
               <a:t>Click to edit Master text styles</a:t>
             </a:r>
           </a:p>
@@ -1051,7 +1705,7 @@
           <a:p>
             <a:fld id="{5BCAD085-E8A6-8845-BD4E-CB4CCA059FC4}" type="datetimeFigureOut">
               <a:rPr lang="en-US" smtClean="0"/>
-              <a:t>1/27/13</a:t>
+              <a:t>7/29/2026</a:t>
             </a:fld>
             <a:endParaRPr lang="en-US"/>
           </a:p>
@@ -1145,10 +1799,9 @@
           <a:lstStyle/>
           <a:p>
             <a:r>
-              <a:rPr lang="en-US" smtClean="0"/>
+              <a:rPr lang="en-US"/>
               <a:t>Click to edit Master title style</a:t>
             </a:r>
-            <a:endParaRPr lang="en-US"/>
           </a:p>
         </p:txBody>
       </p:sp>
@@ -1202,38 +1855,37 @@
           <a:p>
             <a:pPr lvl="0"/>
             <a:r>
-              <a:rPr lang="en-US" smtClean="0"/>
+              <a:rPr lang="en-US"/>
               <a:t>Click to edit Master text styles</a:t>
             </a:r>
           </a:p>
           <a:p>
             <a:pPr lvl="1"/>
             <a:r>
-              <a:rPr lang="en-US" smtClean="0"/>
+              <a:rPr lang="en-US"/>
               <a:t>Second level</a:t>
             </a:r>
           </a:p>
           <a:p>
             <a:pPr lvl="2"/>
             <a:r>
-              <a:rPr lang="en-US" smtClean="0"/>
+              <a:rPr lang="en-US"/>
               <a:t>Third level</a:t>
             </a:r>
           </a:p>
           <a:p>
             <a:pPr lvl="3"/>
             <a:r>
-              <a:rPr lang="en-US" smtClean="0"/>
+              <a:rPr lang="en-US"/>
               <a:t>Fourth level</a:t>
             </a:r>
           </a:p>
           <a:p>
             <a:pPr lvl="4"/>
             <a:r>
-              <a:rPr lang="en-US" smtClean="0"/>
+              <a:rPr lang="en-US"/>
               <a:t>Fifth level</a:t>
             </a:r>
-            <a:endParaRPr lang="en-US"/>
           </a:p>
         </p:txBody>
       </p:sp>
@@ -1287,38 +1939,37 @@
           <a:p>
             <a:pPr lvl="0"/>
             <a:r>
-              <a:rPr lang="en-US" smtClean="0"/>
+              <a:rPr lang="en-US"/>
               <a:t>Click to edit Master text styles</a:t>
             </a:r>
           </a:p>
           <a:p>
             <a:pPr lvl="1"/>
             <a:r>
-              <a:rPr lang="en-US" smtClean="0"/>
+              <a:rPr lang="en-US"/>
               <a:t>Second level</a:t>
             </a:r>
           </a:p>
           <a:p>
             <a:pPr lvl="2"/>
             <a:r>
-              <a:rPr lang="en-US" smtClean="0"/>
+              <a:rPr lang="en-US"/>
               <a:t>Third level</a:t>
             </a:r>
           </a:p>
           <a:p>
             <a:pPr lvl="3"/>
             <a:r>
-              <a:rPr lang="en-US" smtClean="0"/>
+              <a:rPr lang="en-US"/>
               <a:t>Fourth level</a:t>
             </a:r>
           </a:p>
           <a:p>
             <a:pPr lvl="4"/>
             <a:r>
-              <a:rPr lang="en-US" smtClean="0"/>
+              <a:rPr lang="en-US"/>
               <a:t>Fifth level</a:t>
             </a:r>
-            <a:endParaRPr lang="en-US"/>
           </a:p>
         </p:txBody>
       </p:sp>
@@ -1339,7 +1990,7 @@
           <a:p>
             <a:fld id="{5BCAD085-E8A6-8845-BD4E-CB4CCA059FC4}" type="datetimeFigureOut">
               <a:rPr lang="en-US" smtClean="0"/>
-              <a:t>1/27/13</a:t>
+              <a:t>7/29/2026</a:t>
             </a:fld>
             <a:endParaRPr lang="en-US"/>
           </a:p>
@@ -1437,10 +2088,9 @@
           </a:lstStyle>
           <a:p>
             <a:r>
-              <a:rPr lang="en-US" smtClean="0"/>
+              <a:rPr lang="en-US"/>
               <a:t>Click to edit Master title style</a:t>
             </a:r>
-            <a:endParaRPr lang="en-US"/>
           </a:p>
         </p:txBody>
       </p:sp>
@@ -1503,7 +2153,7 @@
           <a:p>
             <a:pPr lvl="0"/>
             <a:r>
-              <a:rPr lang="en-US" smtClean="0"/>
+              <a:rPr lang="en-US"/>
               <a:t>Click to edit Master text styles</a:t>
             </a:r>
           </a:p>
@@ -1559,38 +2209,37 @@
           <a:p>
             <a:pPr lvl="0"/>
             <a:r>
-              <a:rPr lang="en-US" smtClean="0"/>
+              <a:rPr lang="en-US"/>
               <a:t>Click to edit Master text styles</a:t>
             </a:r>
           </a:p>
           <a:p>
             <a:pPr lvl="1"/>
             <a:r>
-              <a:rPr lang="en-US" smtClean="0"/>
+              <a:rPr lang="en-US"/>
               <a:t>Second level</a:t>
             </a:r>
           </a:p>
           <a:p>
             <a:pPr lvl="2"/>
             <a:r>
-              <a:rPr lang="en-US" smtClean="0"/>
+              <a:rPr lang="en-US"/>
               <a:t>Third level</a:t>
             </a:r>
           </a:p>
           <a:p>
             <a:pPr lvl="3"/>
             <a:r>
-              <a:rPr lang="en-US" smtClean="0"/>
+              <a:rPr lang="en-US"/>
               <a:t>Fourth level</a:t>
             </a:r>
           </a:p>
           <a:p>
             <a:pPr lvl="4"/>
             <a:r>
-              <a:rPr lang="en-US" smtClean="0"/>
+              <a:rPr lang="en-US"/>
               <a:t>Fifth level</a:t>
             </a:r>
-            <a:endParaRPr lang="en-US"/>
           </a:p>
         </p:txBody>
       </p:sp>
@@ -1653,7 +2302,7 @@
           <a:p>
             <a:pPr lvl="0"/>
             <a:r>
-              <a:rPr lang="en-US" smtClean="0"/>
+              <a:rPr lang="en-US"/>
               <a:t>Click to edit Master text styles</a:t>
             </a:r>
           </a:p>
@@ -1709,38 +2358,37 @@
           <a:p>
             <a:pPr lvl="0"/>
             <a:r>
-              <a:rPr lang="en-US" smtClean="0"/>
+              <a:rPr lang="en-US"/>
               <a:t>Click to edit Master text styles</a:t>
             </a:r>
           </a:p>
           <a:p>
             <a:pPr lvl="1"/>
             <a:r>
-              <a:rPr lang="en-US" smtClean="0"/>
+              <a:rPr lang="en-US"/>
               <a:t>Second level</a:t>
             </a:r>
           </a:p>
           <a:p>
             <a:pPr lvl="2"/>
             <a:r>
-              <a:rPr lang="en-US" smtClean="0"/>
+              <a:rPr lang="en-US"/>
               <a:t>Third level</a:t>
             </a:r>
           </a:p>
           <a:p>
             <a:pPr lvl="3"/>
             <a:r>
-              <a:rPr lang="en-US" smtClean="0"/>
+              <a:rPr lang="en-US"/>
               <a:t>Fourth level</a:t>
             </a:r>
           </a:p>
           <a:p>
             <a:pPr lvl="4"/>
             <a:r>
-              <a:rPr lang="en-US" smtClean="0"/>
+              <a:rPr lang="en-US"/>
               <a:t>Fifth level</a:t>
             </a:r>
-            <a:endParaRPr lang="en-US"/>
           </a:p>
         </p:txBody>
       </p:sp>
@@ -1761,7 +2409,7 @@
           <a:p>
             <a:fld id="{5BCAD085-E8A6-8845-BD4E-CB4CCA059FC4}" type="datetimeFigureOut">
               <a:rPr lang="en-US" smtClean="0"/>
-              <a:t>1/27/13</a:t>
+              <a:t>7/29/2026</a:t>
             </a:fld>
             <a:endParaRPr lang="en-US"/>
           </a:p>
@@ -1841,22 +2489,39 @@
       </p:grpSpPr>
       <p:sp>
         <p:nvSpPr>
-          <p:cNvPr id="2" name="Title 1"/>
-          <p:cNvSpPr>
-            <a:spLocks noGrp="1"/>
-          </p:cNvSpPr>
-          <p:nvPr>
-            <p:ph type="title"/>
-          </p:nvPr>
-        </p:nvSpPr>
-        <p:spPr/>
-        <p:txBody>
-          <a:bodyPr/>
-          <a:lstStyle/>
-          <a:p>
-            <a:r>
-              <a:rPr lang="en-US" smtClean="0"/>
-              <a:t>Click to edit Master title style</a:t>
+          <p:cNvPr id="2" name="DRB_Title_Placeholder"/>
+          <p:cNvSpPr>
+            <a:spLocks noGrp="1"/>
+          </p:cNvSpPr>
+          <p:nvPr>
+            <p:ph type="title" hasCustomPrompt="1"/>
+          </p:nvPr>
+        </p:nvSpPr>
+        <p:spPr>
+          <a:xfrm>
+            <a:off x="270000" y="342000"/>
+            <a:ext cx="10302000" cy="486000"/>
+          </a:xfrm>
+        </p:spPr>
+        <p:txBody>
+          <a:bodyPr wrap="none" lIns="0" tIns="0" rIns="0" bIns="0" anchor="ctr">
+            <a:noAutofit/>
+          </a:bodyPr>
+          <a:lstStyle>
+            <a:lvl1pPr algn="l">
+              <a:defRPr sz="2800" b="1">
+                <a:solidFill>
+                  <a:srgbClr val="111111"/>
+                </a:solidFill>
+                <a:latin typeface="맑은 고딕" panose="020B0503020000020004" pitchFamily="50" charset="-127"/>
+                <a:ea typeface="맑은 고딕" panose="020B0503020000020004" pitchFamily="50" charset="-127"/>
+              </a:defRPr>
+            </a:lvl1pPr>
+          </a:lstStyle>
+          <a:p>
+            <a:r>
+              <a:rPr lang="ko-KR" altLang="en-US"/>
+              <a:t>슬라이드 제목</a:t>
             </a:r>
             <a:endParaRPr lang="en-US"/>
           </a:p>
@@ -1879,7 +2544,7 @@
           <a:p>
             <a:fld id="{5BCAD085-E8A6-8845-BD4E-CB4CCA059FC4}" type="datetimeFigureOut">
               <a:rPr lang="en-US" smtClean="0"/>
-              <a:t>1/27/13</a:t>
+              <a:t>7/29/2026</a:t>
             </a:fld>
             <a:endParaRPr lang="en-US"/>
           </a:p>
@@ -1924,6 +2589,230 @@
               <a:t>‹#›</a:t>
             </a:fld>
             <a:endParaRPr lang="en-US"/>
+          </a:p>
+        </p:txBody>
+      </p:sp>
+      <p:cxnSp>
+        <p:nvCxnSpPr>
+          <p:cNvPr id="6" name="DRB_Divider">
+            <a:extLst>
+              <a:ext uri="{FF2B5EF4-FFF2-40B4-BE49-F238E27FC236}">
+                <a16:creationId xmlns:a16="http://schemas.microsoft.com/office/drawing/2014/main" id="{5C423C6B-BE15-4EE8-B26F-1A8F2401861F}"/>
+              </a:ext>
+            </a:extLst>
+          </p:cNvPr>
+          <p:cNvCxnSpPr/>
+          <p:nvPr userDrawn="1"/>
+        </p:nvCxnSpPr>
+        <p:spPr>
+          <a:xfrm>
+            <a:off x="336000" y="903600"/>
+            <a:ext cx="11520000" cy="0"/>
+          </a:xfrm>
+          <a:prstGeom prst="line">
+            <a:avLst/>
+          </a:prstGeom>
+          <a:ln w="6350">
+            <a:solidFill>
+              <a:srgbClr val="B7B7B7"/>
+            </a:solidFill>
+          </a:ln>
+          <a:effectLst/>
+          <a:extLst>
+            <a:ext uri="{AF507438-7753-43E0-B8FC-AC1667EBCBE1}">
+              <a14:hiddenEffects xmlns:a14="http://schemas.microsoft.com/office/drawing/2010/main">
+                <a:effectLst>
+                  <a:outerShdw blurRad="40000" dist="20000" dir="5400000" rotWithShape="0">
+                    <a:srgbClr val="000000">
+                      <a:alpha val="38000"/>
+                    </a:srgbClr>
+                  </a:outerShdw>
+                </a:effectLst>
+              </a14:hiddenEffects>
+            </a:ext>
+          </a:extLst>
+        </p:spPr>
+        <p:style>
+          <a:lnRef idx="2">
+            <a:schemeClr val="accent1"/>
+          </a:lnRef>
+          <a:fillRef idx="0">
+            <a:schemeClr val="accent1"/>
+          </a:fillRef>
+          <a:effectRef idx="1">
+            <a:schemeClr val="accent1"/>
+          </a:effectRef>
+          <a:fontRef idx="minor">
+            <a:schemeClr val="tx1"/>
+          </a:fontRef>
+        </p:style>
+      </p:cxnSp>
+      <p:pic>
+        <p:nvPicPr>
+          <p:cNvPr id="8" name="DRB_Samsung_Logo">
+            <a:extLst>
+              <a:ext uri="{FF2B5EF4-FFF2-40B4-BE49-F238E27FC236}">
+                <a16:creationId xmlns:a16="http://schemas.microsoft.com/office/drawing/2014/main" id="{D958198B-4F1F-0A9A-A41F-6FA05FC3CF66}"/>
+              </a:ext>
+            </a:extLst>
+          </p:cNvPr>
+          <p:cNvPicPr>
+            <a:picLocks/>
+          </p:cNvPicPr>
+          <p:nvPr userDrawn="1"/>
+        </p:nvPicPr>
+        <p:blipFill>
+          <a:blip r:embed="rId2"/>
+          <a:stretch>
+            <a:fillRect/>
+          </a:stretch>
+        </p:blipFill>
+        <p:spPr>
+          <a:xfrm>
+            <a:off x="10716000" y="360000"/>
+            <a:ext cx="1162800" cy="198000"/>
+          </a:xfrm>
+          <a:prstGeom prst="rect">
+            <a:avLst/>
+          </a:prstGeom>
+        </p:spPr>
+      </p:pic>
+      <p:sp>
+        <p:nvSpPr>
+          <p:cNvPr id="9" name="DRB_Footer_Message">
+            <a:extLst>
+              <a:ext uri="{FF2B5EF4-FFF2-40B4-BE49-F238E27FC236}">
+                <a16:creationId xmlns:a16="http://schemas.microsoft.com/office/drawing/2014/main" id="{C90DABC8-4AD9-6A58-EC87-52C455740A0F}"/>
+              </a:ext>
+            </a:extLst>
+          </p:cNvPr>
+          <p:cNvSpPr txBox="1"/>
+          <p:nvPr userDrawn="1"/>
+        </p:nvSpPr>
+        <p:spPr>
+          <a:xfrm>
+            <a:off x="439200" y="6462000"/>
+            <a:ext cx="2448000" cy="198000"/>
+          </a:xfrm>
+          <a:prstGeom prst="rect">
+            <a:avLst/>
+          </a:prstGeom>
+          <a:noFill/>
+        </p:spPr>
+        <p:txBody>
+          <a:bodyPr vert="horz" wrap="none" lIns="0" tIns="0" rIns="0" bIns="0" rtlCol="0" anchor="ctr">
+            <a:noAutofit/>
+          </a:bodyPr>
+          <a:lstStyle/>
+          <a:p>
+            <a:pPr algn="l"/>
+            <a:r>
+              <a:rPr lang="ko-KR" altLang="en-US" sz="1200" b="0">
+                <a:solidFill>
+                  <a:srgbClr val="A6A6A6"/>
+                </a:solidFill>
+                <a:latin typeface="맑은 고딕" panose="020B0503020000020004" pitchFamily="50" charset="-127"/>
+                <a:ea typeface="맑은 고딕" panose="020B0503020000020004" pitchFamily="50" charset="-127"/>
+              </a:rPr>
+              <a:t>함께 성장하는 행복한 메모리사업부</a:t>
+            </a:r>
+          </a:p>
+        </p:txBody>
+      </p:sp>
+      <p:sp>
+        <p:nvSpPr>
+          <p:cNvPr id="10" name="DRB_Confidential">
+            <a:extLst>
+              <a:ext uri="{FF2B5EF4-FFF2-40B4-BE49-F238E27FC236}">
+                <a16:creationId xmlns:a16="http://schemas.microsoft.com/office/drawing/2014/main" id="{298B1028-FFE7-D7AF-BBA9-8B2607B45835}"/>
+              </a:ext>
+            </a:extLst>
+          </p:cNvPr>
+          <p:cNvSpPr txBox="1"/>
+          <p:nvPr userDrawn="1"/>
+        </p:nvSpPr>
+        <p:spPr>
+          <a:xfrm>
+            <a:off x="10842000" y="6422400"/>
+            <a:ext cx="1152000" cy="237600"/>
+          </a:xfrm>
+          <a:prstGeom prst="rect">
+            <a:avLst/>
+          </a:prstGeom>
+          <a:noFill/>
+        </p:spPr>
+        <p:txBody>
+          <a:bodyPr vert="horz" wrap="none" lIns="0" tIns="0" rIns="0" bIns="0" rtlCol="0" anchor="ctr">
+            <a:noAutofit/>
+          </a:bodyPr>
+          <a:lstStyle/>
+          <a:p>
+            <a:pPr algn="r"/>
+            <a:r>
+              <a:rPr lang="en-US" altLang="ko-KR" sz="1200" b="1">
+                <a:solidFill>
+                  <a:srgbClr val="E17D7D"/>
+                </a:solidFill>
+                <a:latin typeface="맑은 고딕" panose="020B0503020000020004" pitchFamily="50" charset="-127"/>
+                <a:ea typeface="맑은 고딕" panose="020B0503020000020004" pitchFamily="50" charset="-127"/>
+              </a:rPr>
+              <a:t>Confidential</a:t>
+            </a:r>
+            <a:endParaRPr lang="ko-KR" altLang="en-US" sz="1200" b="1">
+              <a:solidFill>
+                <a:srgbClr val="E17D7D"/>
+              </a:solidFill>
+              <a:latin typeface="맑은 고딕" panose="020B0503020000020004" pitchFamily="50" charset="-127"/>
+              <a:ea typeface="맑은 고딕" panose="020B0503020000020004" pitchFamily="50" charset="-127"/>
+            </a:endParaRPr>
+          </a:p>
+        </p:txBody>
+      </p:sp>
+      <p:sp>
+        <p:nvSpPr>
+          <p:cNvPr id="11" name="DRB_Body_Placeholder">
+            <a:extLst>
+              <a:ext uri="{FF2B5EF4-FFF2-40B4-BE49-F238E27FC236}">
+                <a16:creationId xmlns:a16="http://schemas.microsoft.com/office/drawing/2014/main" id="{E155BF77-A51A-D56F-58EB-6AD12F6E2296}"/>
+              </a:ext>
+            </a:extLst>
+          </p:cNvPr>
+          <p:cNvSpPr>
+            <a:spLocks noGrp="1"/>
+          </p:cNvSpPr>
+          <p:nvPr>
+            <p:ph idx="13" hasCustomPrompt="1"/>
+          </p:nvPr>
+        </p:nvSpPr>
+        <p:spPr>
+          <a:xfrm>
+            <a:off x="270000" y="943200"/>
+            <a:ext cx="11520000" cy="583200"/>
+          </a:xfrm>
+        </p:spPr>
+        <p:txBody>
+          <a:bodyPr wrap="none" lIns="0" tIns="0" rIns="0" bIns="0" anchor="ctr">
+            <a:noAutofit/>
+          </a:bodyPr>
+          <a:lstStyle>
+            <a:lvl1pPr marL="0" indent="0" algn="l">
+              <a:buFontTx/>
+              <a:buNone/>
+              <a:defRPr sz="1300" b="1">
+                <a:solidFill>
+                  <a:srgbClr val="333333"/>
+                </a:solidFill>
+                <a:latin typeface="맑은 고딕" panose="020B0503020000020004" pitchFamily="50" charset="-127"/>
+                <a:ea typeface="맑은 고딕" panose="020B0503020000020004" pitchFamily="50" charset="-127"/>
+              </a:defRPr>
+            </a:lvl1pPr>
+          </a:lstStyle>
+          <a:p>
+            <a:pPr lvl="0"/>
+            <a:r>
+              <a:rPr lang="ko-KR" altLang="en-US"/>
+              <a:t>■ 본문</a:t>
+            </a:r>
           </a:p>
         </p:txBody>
       </p:sp>
@@ -1974,7 +2863,7 @@
           <a:p>
             <a:fld id="{5BCAD085-E8A6-8845-BD4E-CB4CCA059FC4}" type="datetimeFigureOut">
               <a:rPr lang="en-US" smtClean="0"/>
-              <a:t>1/27/13</a:t>
+              <a:t>7/29/2026</a:t>
             </a:fld>
             <a:endParaRPr lang="en-US"/>
           </a:p>
@@ -2077,10 +2966,9 @@
           </a:lstStyle>
           <a:p>
             <a:r>
-              <a:rPr lang="en-US" smtClean="0"/>
+              <a:rPr lang="en-US"/>
               <a:t>Click to edit Master title style</a:t>
             </a:r>
-            <a:endParaRPr lang="en-US"/>
           </a:p>
         </p:txBody>
       </p:sp>
@@ -2134,38 +3022,37 @@
           <a:p>
             <a:pPr lvl="0"/>
             <a:r>
-              <a:rPr lang="en-US" smtClean="0"/>
+              <a:rPr lang="en-US"/>
               <a:t>Click to edit Master text styles</a:t>
             </a:r>
           </a:p>
           <a:p>
             <a:pPr lvl="1"/>
             <a:r>
-              <a:rPr lang="en-US" smtClean="0"/>
+              <a:rPr lang="en-US"/>
               <a:t>Second level</a:t>
             </a:r>
           </a:p>
           <a:p>
             <a:pPr lvl="2"/>
             <a:r>
-              <a:rPr lang="en-US" smtClean="0"/>
+              <a:rPr lang="en-US"/>
               <a:t>Third level</a:t>
             </a:r>
           </a:p>
           <a:p>
             <a:pPr lvl="3"/>
             <a:r>
-              <a:rPr lang="en-US" smtClean="0"/>
+              <a:rPr lang="en-US"/>
               <a:t>Fourth level</a:t>
             </a:r>
           </a:p>
           <a:p>
             <a:pPr lvl="4"/>
             <a:r>
-              <a:rPr lang="en-US" smtClean="0"/>
+              <a:rPr lang="en-US"/>
               <a:t>Fifth level</a:t>
             </a:r>
-            <a:endParaRPr lang="en-US"/>
           </a:p>
         </p:txBody>
       </p:sp>
@@ -2228,7 +3115,7 @@
           <a:p>
             <a:pPr lvl="0"/>
             <a:r>
-              <a:rPr lang="en-US" smtClean="0"/>
+              <a:rPr lang="en-US"/>
               <a:t>Click to edit Master text styles</a:t>
             </a:r>
           </a:p>
@@ -2251,7 +3138,7 @@
           <a:p>
             <a:fld id="{5BCAD085-E8A6-8845-BD4E-CB4CCA059FC4}" type="datetimeFigureOut">
               <a:rPr lang="en-US" smtClean="0"/>
-              <a:t>1/27/13</a:t>
+              <a:t>7/29/2026</a:t>
             </a:fld>
             <a:endParaRPr lang="en-US"/>
           </a:p>
@@ -2354,10 +3241,9 @@
           </a:lstStyle>
           <a:p>
             <a:r>
-              <a:rPr lang="en-US" smtClean="0"/>
+              <a:rPr lang="en-US"/>
               <a:t>Click to edit Master title style</a:t>
             </a:r>
-            <a:endParaRPr lang="en-US"/>
           </a:p>
         </p:txBody>
       </p:sp>
@@ -2481,7 +3367,7 @@
           <a:p>
             <a:pPr lvl="0"/>
             <a:r>
-              <a:rPr lang="en-US" smtClean="0"/>
+              <a:rPr lang="en-US"/>
               <a:t>Click to edit Master text styles</a:t>
             </a:r>
           </a:p>
@@ -2504,7 +3390,7 @@
           <a:p>
             <a:fld id="{5BCAD085-E8A6-8845-BD4E-CB4CCA059FC4}" type="datetimeFigureOut">
               <a:rPr lang="en-US" smtClean="0"/>
-              <a:t>1/27/13</a:t>
+              <a:t>7/29/2026</a:t>
             </a:fld>
             <a:endParaRPr lang="en-US"/>
           </a:p>
@@ -2613,10 +3499,9 @@
           <a:lstStyle/>
           <a:p>
             <a:r>
-              <a:rPr lang="en-US" smtClean="0"/>
+              <a:rPr lang="en-US"/>
               <a:t>Click to edit Master title style</a:t>
             </a:r>
-            <a:endParaRPr lang="en-US"/>
           </a:p>
         </p:txBody>
       </p:sp>
@@ -2647,38 +3532,37 @@
           <a:p>
             <a:pPr lvl="0"/>
             <a:r>
-              <a:rPr lang="en-US" smtClean="0"/>
+              <a:rPr lang="en-US"/>
               <a:t>Click to edit Master text styles</a:t>
             </a:r>
           </a:p>
           <a:p>
             <a:pPr lvl="1"/>
             <a:r>
-              <a:rPr lang="en-US" smtClean="0"/>
+              <a:rPr lang="en-US"/>
               <a:t>Second level</a:t>
             </a:r>
           </a:p>
           <a:p>
             <a:pPr lvl="2"/>
             <a:r>
-              <a:rPr lang="en-US" smtClean="0"/>
+              <a:rPr lang="en-US"/>
               <a:t>Third level</a:t>
             </a:r>
           </a:p>
           <a:p>
             <a:pPr lvl="3"/>
             <a:r>
-              <a:rPr lang="en-US" smtClean="0"/>
+              <a:rPr lang="en-US"/>
               <a:t>Fourth level</a:t>
             </a:r>
           </a:p>
           <a:p>
             <a:pPr lvl="4"/>
             <a:r>
-              <a:rPr lang="en-US" smtClean="0"/>
+              <a:rPr lang="en-US"/>
               <a:t>Fifth level</a:t>
             </a:r>
-            <a:endParaRPr lang="en-US"/>
           </a:p>
         </p:txBody>
       </p:sp>
@@ -2717,7 +3601,7 @@
           <a:p>
             <a:fld id="{5BCAD085-E8A6-8845-BD4E-CB4CCA059FC4}" type="datetimeFigureOut">
               <a:rPr lang="en-US" smtClean="0"/>
-              <a:t>1/27/13</a:t>
+              <a:t>7/29/2026</a:t>
             </a:fld>
             <a:endParaRPr lang="en-US"/>
           </a:p>
@@ -3073,6 +3957,172 @@
     </p:otherStyle>
   </p:txStyles>
 </p:sldMaster>
+</file>
+
+<file path=ppt/slides/slide1.xml><?xml version="1.0" encoding="utf-8"?>
+<p:sld xmlns:a="http://schemas.openxmlformats.org/drawingml/2006/main" xmlns:r="http://schemas.openxmlformats.org/officeDocument/2006/relationships" xmlns:p="http://schemas.openxmlformats.org/presentationml/2006/main">
+  <p:cSld>
+    <p:spTree>
+      <p:nvGrpSpPr>
+        <p:cNvPr id="1" name=""/>
+        <p:cNvGrpSpPr/>
+        <p:nvPr/>
+      </p:nvGrpSpPr>
+      <p:grpSpPr>
+        <a:xfrm>
+          <a:off x="0" y="0"/>
+          <a:ext cx="0" cy="0"/>
+          <a:chOff x="0" y="0"/>
+          <a:chExt cx="0" cy="0"/>
+        </a:xfrm>
+      </p:grpSpPr>
+      <p:sp>
+        <p:nvSpPr>
+          <p:cNvPr id="2" name="제목 1">
+            <a:extLst>
+              <a:ext uri="{FF2B5EF4-FFF2-40B4-BE49-F238E27FC236}">
+                <a16:creationId xmlns:a16="http://schemas.microsoft.com/office/drawing/2014/main" id="{A63DC396-DA84-3DE2-5DA2-24A9ABBD6DF5}"/>
+              </a:ext>
+            </a:extLst>
+          </p:cNvPr>
+          <p:cNvSpPr>
+            <a:spLocks noGrp="1"/>
+          </p:cNvSpPr>
+          <p:nvPr>
+            <p:ph type="title"/>
+          </p:nvPr>
+        </p:nvSpPr>
+        <p:spPr/>
+        <p:txBody>
+          <a:bodyPr/>
+          <a:lstStyle/>
+          <a:p>
+            <a:r>
+              <a:rPr lang="en-US" altLang="ko-KR"/>
+              <a:t>[DM] Data Review Board Auto Report</a:t>
+            </a:r>
+            <a:endParaRPr lang="ko-KR" altLang="en-US"/>
+          </a:p>
+        </p:txBody>
+      </p:sp>
+      <p:sp>
+        <p:nvSpPr>
+          <p:cNvPr id="3" name="내용 개체 틀 2">
+            <a:extLst>
+              <a:ext uri="{FF2B5EF4-FFF2-40B4-BE49-F238E27FC236}">
+                <a16:creationId xmlns:a16="http://schemas.microsoft.com/office/drawing/2014/main" id="{9EEF82D1-D092-C46D-C9A9-3C7E08FF1387}"/>
+              </a:ext>
+            </a:extLst>
+          </p:cNvPr>
+          <p:cNvSpPr>
+            <a:spLocks noGrp="1"/>
+          </p:cNvSpPr>
+          <p:nvPr>
+            <p:ph idx="1"/>
+          </p:nvPr>
+        </p:nvSpPr>
+        <p:spPr/>
+        <p:txBody>
+          <a:bodyPr/>
+          <a:lstStyle/>
+          <a:p>
+            <a:r>
+              <a:rPr lang="en-US" altLang="ko-KR"/>
+              <a:t>■ REF: Reference / TARGET: Target | Threshold: 0.5</a:t>
+            </a:r>
+          </a:p>
+          <a:p>
+            <a:r>
+              <a:rPr lang="en-US" altLang="ko-KR"/>
+              <a:t>■ Category: Sample | Showing MSR 1-8 of 8</a:t>
+            </a:r>
+            <a:endParaRPr lang="ko-KR" altLang="en-US"/>
+          </a:p>
+        </p:txBody>
+      </p:sp>
+      <p:sp>
+        <p:nvSpPr>
+          <p:cNvPr id="4" name="DRB_Affiliation_Sample">
+            <a:extLst>
+              <a:ext uri="{FF2B5EF4-FFF2-40B4-BE49-F238E27FC236}">
+                <a16:creationId xmlns:a16="http://schemas.microsoft.com/office/drawing/2014/main" id="{8100EAB6-C37E-A01D-88D2-26A953BFFEF2}"/>
+              </a:ext>
+            </a:extLst>
+          </p:cNvPr>
+          <p:cNvSpPr txBox="1"/>
+          <p:nvPr/>
+        </p:nvSpPr>
+        <p:spPr>
+          <a:xfrm>
+            <a:off x="8267999" y="6451200"/>
+            <a:ext cx="2520000" cy="237600"/>
+          </a:xfrm>
+          <a:prstGeom prst="rect">
+            <a:avLst/>
+          </a:prstGeom>
+          <a:noFill/>
+        </p:spPr>
+        <p:txBody>
+          <a:bodyPr vert="horz" wrap="none" lIns="0" tIns="0" rIns="0" bIns="0" rtlCol="0" anchor="ctr">
+            <a:noAutofit/>
+          </a:bodyPr>
+          <a:lstStyle/>
+          <a:p>
+            <a:pPr algn="r"/>
+            <a:r>
+              <a:rPr lang="en-US" altLang="ko-KR" sz="1200">
+                <a:solidFill>
+                  <a:srgbClr val="7F7F7F"/>
+                </a:solidFill>
+                <a:latin typeface="맑은 고딕" panose="020B0503020000020004" pitchFamily="50" charset="-127"/>
+                <a:ea typeface="맑은 고딕" panose="020B0503020000020004" pitchFamily="50" charset="-127"/>
+              </a:rPr>
+              <a:t>Flash PE</a:t>
+            </a:r>
+            <a:r>
+              <a:rPr lang="ko-KR" altLang="en-US" sz="1200">
+                <a:solidFill>
+                  <a:srgbClr val="7F7F7F"/>
+                </a:solidFill>
+                <a:latin typeface="맑은 고딕" panose="020B0503020000020004" pitchFamily="50" charset="-127"/>
+                <a:ea typeface="맑은 고딕" panose="020B0503020000020004" pitchFamily="50" charset="-127"/>
+              </a:rPr>
+              <a:t>팀 </a:t>
+            </a:r>
+            <a:r>
+              <a:rPr lang="en-US" altLang="ko-KR" sz="1200">
+                <a:solidFill>
+                  <a:srgbClr val="7F7F7F"/>
+                </a:solidFill>
+                <a:latin typeface="맑은 고딕" panose="020B0503020000020004" pitchFamily="50" charset="-127"/>
+                <a:ea typeface="맑은 고딕" panose="020B0503020000020004" pitchFamily="50" charset="-127"/>
+              </a:rPr>
+              <a:t>/ </a:t>
+            </a:r>
+            <a:r>
+              <a:rPr lang="ko-KR" altLang="en-US" sz="1200">
+                <a:solidFill>
+                  <a:srgbClr val="7F7F7F"/>
+                </a:solidFill>
+                <a:latin typeface="맑은 고딕" panose="020B0503020000020004" pitchFamily="50" charset="-127"/>
+                <a:ea typeface="맑은 고딕" panose="020B0503020000020004" pitchFamily="50" charset="-127"/>
+              </a:rPr>
+              <a:t>홍길동</a:t>
+            </a:r>
+          </a:p>
+        </p:txBody>
+      </p:sp>
+    </p:spTree>
+    <p:extLst>
+      <p:ext uri="{BB962C8B-B14F-4D97-AF65-F5344CB8AC3E}">
+        <p14:creationId xmlns:p14="http://schemas.microsoft.com/office/powerpoint/2010/main" val="3927136239"/>
+      </p:ext>
+    </p:extLst>
+  </p:cSld>
+  <p:clrMapOvr>
+    <a:masterClrMapping/>
+  </p:clrMapOvr>
+</p:sld>
 </file>
 
 <file path=ppt/theme/theme1.xml><?xml version="1.0" encoding="utf-8"?>
@@ -3393,4 +4443,299 @@
   </a:objectDefaults>
   <a:extraClrSchemeLst/>
 </a:theme>
+</file>
+
+<file path=ppt/theme/theme2.xml><?xml version="1.0" encoding="utf-8"?>
+<a:theme xmlns:a="http://schemas.openxmlformats.org/drawingml/2006/main" name="Office 테마">
+  <a:themeElements>
+    <a:clrScheme name="Office">
+      <a:dk1>
+        <a:sysClr val="windowText" lastClr="000000"/>
+      </a:dk1>
+      <a:lt1>
+        <a:sysClr val="window" lastClr="FFFFFF"/>
+      </a:lt1>
+      <a:dk2>
+        <a:srgbClr val="44546A"/>
+      </a:dk2>
+      <a:lt2>
+        <a:srgbClr val="E7E6E6"/>
+      </a:lt2>
+      <a:accent1>
+        <a:srgbClr val="4472C4"/>
+      </a:accent1>
+      <a:accent2>
+        <a:srgbClr val="ED7D31"/>
+      </a:accent2>
+      <a:accent3>
+        <a:srgbClr val="A5A5A5"/>
+      </a:accent3>
+      <a:accent4>
+        <a:srgbClr val="FFC000"/>
+      </a:accent4>
+      <a:accent5>
+        <a:srgbClr val="5B9BD5"/>
+      </a:accent5>
+      <a:accent6>
+        <a:srgbClr val="70AD47"/>
+      </a:accent6>
+      <a:hlink>
+        <a:srgbClr val="0563C1"/>
+      </a:hlink>
+      <a:folHlink>
+        <a:srgbClr val="954F72"/>
+      </a:folHlink>
+    </a:clrScheme>
+    <a:fontScheme name="Office">
+      <a:majorFont>
+        <a:latin typeface="맑은 고딕" panose="020F0302020204030204"/>
+        <a:ea typeface=""/>
+        <a:cs typeface=""/>
+        <a:font script="Jpan" typeface="游ゴシック Light"/>
+        <a:font script="Hang" typeface="맑은 고딕"/>
+        <a:font script="Hans" typeface="等线 Light"/>
+        <a:font script="Hant" typeface="新細明體"/>
+        <a:font script="Arab" typeface="Times New Roman"/>
+        <a:font script="Hebr" typeface="Times New Roman"/>
+        <a:font script="Thai" typeface="Angsana New"/>
+        <a:font script="Ethi" typeface="Nyala"/>
+        <a:font script="Beng" typeface="Vrinda"/>
+        <a:font script="Gujr" typeface="Shruti"/>
+        <a:font script="Khmr" typeface="MoolBoran"/>
+        <a:font script="Knda" typeface="Tunga"/>
+        <a:font script="Guru" typeface="Raavi"/>
+        <a:font script="Cans" typeface="Euphemia"/>
+        <a:font script="Cher" typeface="Plantagenet Cherokee"/>
+        <a:font script="Yiii" typeface="Microsoft Yi Baiti"/>
+        <a:font script="Tibt" typeface="Microsoft Himalaya"/>
+        <a:font script="Thaa" typeface="MV Boli"/>
+        <a:font script="Deva" typeface="Mangal"/>
+        <a:font script="Telu" typeface="Gautami"/>
+        <a:font script="Taml" typeface="Latha"/>
+        <a:font script="Syrc" typeface="Estrangelo Edessa"/>
+        <a:font script="Orya" typeface="Kalinga"/>
+        <a:font script="Mlym" typeface="Kartika"/>
+        <a:font script="Laoo" typeface="DokChampa"/>
+        <a:font script="Sinh" typeface="Iskoola Pota"/>
+        <a:font script="Mong" typeface="Mongolian Baiti"/>
+        <a:font script="Viet" typeface="Times New Roman"/>
+        <a:font script="Uigh" typeface="Microsoft Uighur"/>
+        <a:font script="Geor" typeface="Sylfaen"/>
+        <a:font script="Armn" typeface="Arial"/>
+        <a:font script="Bugi" typeface="Leelawadee UI"/>
+        <a:font script="Bopo" typeface="Microsoft JhengHei"/>
+        <a:font script="Java" typeface="Javanese Text"/>
+        <a:font script="Lisu" typeface="Segoe UI"/>
+        <a:font script="Mymr" typeface="Myanmar Text"/>
+        <a:font script="Nkoo" typeface="Ebrima"/>
+        <a:font script="Olck" typeface="Nirmala UI"/>
+        <a:font script="Osma" typeface="Ebrima"/>
+        <a:font script="Phag" typeface="Phagspa"/>
+        <a:font script="Syrn" typeface="Estrangelo Edessa"/>
+        <a:font script="Syrj" typeface="Estrangelo Edessa"/>
+        <a:font script="Syre" typeface="Estrangelo Edessa"/>
+        <a:font script="Sora" typeface="Nirmala UI"/>
+        <a:font script="Tale" typeface="Microsoft Tai Le"/>
+        <a:font script="Talu" typeface="Microsoft New Tai Lue"/>
+        <a:font script="Tfng" typeface="Ebrima"/>
+      </a:majorFont>
+      <a:minorFont>
+        <a:latin typeface="맑은 고딕" panose="020F0502020204030204"/>
+        <a:ea typeface=""/>
+        <a:cs typeface=""/>
+        <a:font script="Jpan" typeface="游ゴシック"/>
+        <a:font script="Hang" typeface="맑은 고딕"/>
+        <a:font script="Hans" typeface="等线"/>
+        <a:font script="Hant" typeface="新細明體"/>
+        <a:font script="Arab" typeface="Arial"/>
+        <a:font script="Hebr" typeface="Arial"/>
+        <a:font script="Thai" typeface="Cordia New"/>
+        <a:font script="Ethi" typeface="Nyala"/>
+        <a:font script="Beng" typeface="Vrinda"/>
+        <a:font script="Gujr" typeface="Shruti"/>
+        <a:font script="Khmr" typeface="DaunPenh"/>
+        <a:font script="Knda" typeface="Tunga"/>
+        <a:font script="Guru" typeface="Raavi"/>
+        <a:font script="Cans" typeface="Euphemia"/>
+        <a:font script="Cher" typeface="Plantagenet Cherokee"/>
+        <a:font script="Yiii" typeface="Microsoft Yi Baiti"/>
+        <a:font script="Tibt" typeface="Microsoft Himalaya"/>
+        <a:font script="Thaa" typeface="MV Boli"/>
+        <a:font script="Deva" typeface="Mangal"/>
+        <a:font script="Telu" typeface="Gautami"/>
+        <a:font script="Taml" typeface="Latha"/>
+        <a:font script="Syrc" typeface="Estrangelo Edessa"/>
+        <a:font script="Orya" typeface="Kalinga"/>
+        <a:font script="Mlym" typeface="Kartika"/>
+        <a:font script="Laoo" typeface="DokChampa"/>
+        <a:font script="Sinh" typeface="Iskoola Pota"/>
+        <a:font script="Mong" typeface="Mongolian Baiti"/>
+        <a:font script="Viet" typeface="Arial"/>
+        <a:font script="Uigh" typeface="Microsoft Uighur"/>
+        <a:font script="Geor" typeface="Sylfaen"/>
+        <a:font script="Armn" typeface="Arial"/>
+        <a:font script="Bugi" typeface="Leelawadee UI"/>
+        <a:font script="Bopo" typeface="Microsoft JhengHei"/>
+        <a:font script="Java" typeface="Javanese Text"/>
+        <a:font script="Lisu" typeface="Segoe UI"/>
+        <a:font script="Mymr" typeface="Myanmar Text"/>
+        <a:font script="Nkoo" typeface="Ebrima"/>
+        <a:font script="Olck" typeface="Nirmala UI"/>
+        <a:font script="Osma" typeface="Ebrima"/>
+        <a:font script="Phag" typeface="Phagspa"/>
+        <a:font script="Syrn" typeface="Estrangelo Edessa"/>
+        <a:font script="Syrj" typeface="Estrangelo Edessa"/>
+        <a:font script="Syre" typeface="Estrangelo Edessa"/>
+        <a:font script="Sora" typeface="Nirmala UI"/>
+        <a:font script="Tale" typeface="Microsoft Tai Le"/>
+        <a:font script="Talu" typeface="Microsoft New Tai Lue"/>
+        <a:font script="Tfng" typeface="Ebrima"/>
+      </a:minorFont>
+    </a:fontScheme>
+    <a:fmtScheme name="Office">
+      <a:fillStyleLst>
+        <a:solidFill>
+          <a:schemeClr val="phClr"/>
+        </a:solidFill>
+        <a:gradFill rotWithShape="1">
+          <a:gsLst>
+            <a:gs pos="0">
+              <a:schemeClr val="phClr">
+                <a:lumMod val="110000"/>
+                <a:satMod val="105000"/>
+                <a:tint val="67000"/>
+              </a:schemeClr>
+            </a:gs>
+            <a:gs pos="50000">
+              <a:schemeClr val="phClr">
+                <a:lumMod val="105000"/>
+                <a:satMod val="103000"/>
+                <a:tint val="73000"/>
+              </a:schemeClr>
+            </a:gs>
+            <a:gs pos="100000">
+              <a:schemeClr val="phClr">
+                <a:lumMod val="105000"/>
+                <a:satMod val="109000"/>
+                <a:tint val="81000"/>
+              </a:schemeClr>
+            </a:gs>
+          </a:gsLst>
+          <a:lin ang="5400000" scaled="0"/>
+        </a:gradFill>
+        <a:gradFill rotWithShape="1">
+          <a:gsLst>
+            <a:gs pos="0">
+              <a:schemeClr val="phClr">
+                <a:satMod val="103000"/>
+                <a:lumMod val="102000"/>
+                <a:tint val="94000"/>
+              </a:schemeClr>
+            </a:gs>
+            <a:gs pos="50000">
+              <a:schemeClr val="phClr">
+                <a:satMod val="110000"/>
+                <a:lumMod val="100000"/>
+                <a:shade val="100000"/>
+              </a:schemeClr>
+            </a:gs>
+            <a:gs pos="100000">
+              <a:schemeClr val="phClr">
+                <a:lumMod val="99000"/>
+                <a:satMod val="120000"/>
+                <a:shade val="78000"/>
+              </a:schemeClr>
+            </a:gs>
+          </a:gsLst>
+          <a:lin ang="5400000" scaled="0"/>
+        </a:gradFill>
+      </a:fillStyleLst>
+      <a:lnStyleLst>
+        <a:ln w="6350" cap="flat" cmpd="sng" algn="ctr">
+          <a:solidFill>
+            <a:schemeClr val="phClr"/>
+          </a:solidFill>
+          <a:prstDash val="solid"/>
+          <a:miter lim="800000"/>
+        </a:ln>
+        <a:ln w="12700" cap="flat" cmpd="sng" algn="ctr">
+          <a:solidFill>
+            <a:schemeClr val="phClr"/>
+          </a:solidFill>
+          <a:prstDash val="solid"/>
+          <a:miter lim="800000"/>
+        </a:ln>
+        <a:ln w="19050" cap="flat" cmpd="sng" algn="ctr">
+          <a:solidFill>
+            <a:schemeClr val="phClr"/>
+          </a:solidFill>
+          <a:prstDash val="solid"/>
+          <a:miter lim="800000"/>
+        </a:ln>
+      </a:lnStyleLst>
+      <a:effectStyleLst>
+        <a:effectStyle>
+          <a:effectLst/>
+        </a:effectStyle>
+        <a:effectStyle>
+          <a:effectLst/>
+        </a:effectStyle>
+        <a:effectStyle>
+          <a:effectLst>
+            <a:outerShdw blurRad="57150" dist="19050" dir="5400000" algn="ctr" rotWithShape="0">
+              <a:srgbClr val="000000">
+                <a:alpha val="63000"/>
+              </a:srgbClr>
+            </a:outerShdw>
+          </a:effectLst>
+        </a:effectStyle>
+      </a:effectStyleLst>
+      <a:bgFillStyleLst>
+        <a:solidFill>
+          <a:schemeClr val="phClr"/>
+        </a:solidFill>
+        <a:solidFill>
+          <a:schemeClr val="phClr">
+            <a:tint val="95000"/>
+            <a:satMod val="170000"/>
+          </a:schemeClr>
+        </a:solidFill>
+        <a:gradFill rotWithShape="1">
+          <a:gsLst>
+            <a:gs pos="0">
+              <a:schemeClr val="phClr">
+                <a:tint val="93000"/>
+                <a:satMod val="150000"/>
+                <a:shade val="98000"/>
+                <a:lumMod val="102000"/>
+              </a:schemeClr>
+            </a:gs>
+            <a:gs pos="50000">
+              <a:schemeClr val="phClr">
+                <a:tint val="98000"/>
+                <a:satMod val="130000"/>
+                <a:shade val="90000"/>
+                <a:lumMod val="103000"/>
+              </a:schemeClr>
+            </a:gs>
+            <a:gs pos="100000">
+              <a:schemeClr val="phClr">
+                <a:shade val="63000"/>
+                <a:satMod val="120000"/>
+              </a:schemeClr>
+            </a:gs>
+          </a:gsLst>
+          <a:lin ang="5400000" scaled="0"/>
+        </a:gradFill>
+      </a:bgFillStyleLst>
+    </a:fmtScheme>
+  </a:themeElements>
+  <a:objectDefaults/>
+  <a:extraClrSchemeLst/>
+  <a:extLst>
+    <a:ext uri="{05A4C25C-085E-4340-85A3-A5531E510DB2}">
+      <thm15:themeFamily xmlns:thm15="http://schemas.microsoft.com/office/thememl/2012/main" name="Office Theme" id="{62F939B6-93AF-4DB8-9C6B-D6C7DFDC589F}" vid="{4A3C46E8-61CC-4603-A589-7422A47A8E4A}"/>
+    </a:ext>
+  </a:extLst>
+</a:theme>
 </file>
</xml_diff>

<commit_message>
Add PPT scatter controls and mean annotations
</commit_message>
<xml_diff>
--- a/data/template_16_9.pptx
+++ b/data/template_16_9.pptx
@@ -571,7 +571,7 @@
     </p:spTree>
     <p:extLst>
       <p:ext uri="{BB962C8B-B14F-4D97-AF65-F5344CB8AC3E}">
-        <p14:creationId xmlns:p14="http://schemas.microsoft.com/office/powerpoint/2010/main" val="3532351417"/>
+        <p14:creationId xmlns:p14="http://schemas.microsoft.com/office/powerpoint/2010/main" val="4244756395"/>
       </p:ext>
     </p:extLst>
   </p:cSld>
@@ -1334,10 +1334,10 @@
       </p:sp>
       <p:cxnSp>
         <p:nvCxnSpPr>
-          <p:cNvPr id="7" name="DRB_Divider">
+          <p:cNvPr id="8" name="DRB_Divider">
             <a:extLst>
               <a:ext uri="{FF2B5EF4-FFF2-40B4-BE49-F238E27FC236}">
-                <a16:creationId xmlns:a16="http://schemas.microsoft.com/office/drawing/2014/main" id="{6D198FB5-2C2E-6433-70CD-E9732C4D68C8}"/>
+                <a16:creationId xmlns:a16="http://schemas.microsoft.com/office/drawing/2014/main" id="{56B9C05E-96DE-C606-E94C-2073B80F8DE6}"/>
               </a:ext>
             </a:extLst>
           </p:cNvPr>
@@ -1389,10 +1389,10 @@
       </p:cxnSp>
       <p:pic>
         <p:nvPicPr>
-          <p:cNvPr id="9" name="DRB_Samsung_Logo">
+          <p:cNvPr id="13" name="DRB_Samsung_Logo">
             <a:extLst>
               <a:ext uri="{FF2B5EF4-FFF2-40B4-BE49-F238E27FC236}">
-                <a16:creationId xmlns:a16="http://schemas.microsoft.com/office/drawing/2014/main" id="{E595D573-1678-7A0D-5560-1618FDE4C116}"/>
+                <a16:creationId xmlns:a16="http://schemas.microsoft.com/office/drawing/2014/main" id="{E0CD44E5-E9D7-8D84-782F-DC6CFC89B218}"/>
               </a:ext>
             </a:extLst>
           </p:cNvPr>
@@ -1419,10 +1419,10 @@
       </p:pic>
       <p:sp>
         <p:nvSpPr>
-          <p:cNvPr id="10" name="DRB_Footer_Message">
+          <p:cNvPr id="14" name="DRB_Footer_Message">
             <a:extLst>
               <a:ext uri="{FF2B5EF4-FFF2-40B4-BE49-F238E27FC236}">
-                <a16:creationId xmlns:a16="http://schemas.microsoft.com/office/drawing/2014/main" id="{9E7B8FAD-DAA3-690C-7B7D-865BF8591144}"/>
+                <a16:creationId xmlns:a16="http://schemas.microsoft.com/office/drawing/2014/main" id="{09F0CB29-D2DE-4D53-11FC-12393E653311}"/>
               </a:ext>
             </a:extLst>
           </p:cNvPr>
@@ -1461,10 +1461,10 @@
       </p:sp>
       <p:sp>
         <p:nvSpPr>
-          <p:cNvPr id="11" name="DRB_Confidential">
+          <p:cNvPr id="15" name="DRB_Confidential">
             <a:extLst>
               <a:ext uri="{FF2B5EF4-FFF2-40B4-BE49-F238E27FC236}">
-                <a16:creationId xmlns:a16="http://schemas.microsoft.com/office/drawing/2014/main" id="{9F399E75-B9CE-5940-1934-24EA33AB0E46}"/>
+                <a16:creationId xmlns:a16="http://schemas.microsoft.com/office/drawing/2014/main" id="{000E919A-31A1-E63B-D34D-52261D514934}"/>
               </a:ext>
             </a:extLst>
           </p:cNvPr>
@@ -2592,12 +2592,60 @@
           </a:p>
         </p:txBody>
       </p:sp>
+      <p:sp>
+        <p:nvSpPr>
+          <p:cNvPr id="11" name="DRB_Body_Placeholder">
+            <a:extLst>
+              <a:ext uri="{FF2B5EF4-FFF2-40B4-BE49-F238E27FC236}">
+                <a16:creationId xmlns:a16="http://schemas.microsoft.com/office/drawing/2014/main" id="{E155BF77-A51A-D56F-58EB-6AD12F6E2296}"/>
+              </a:ext>
+            </a:extLst>
+          </p:cNvPr>
+          <p:cNvSpPr>
+            <a:spLocks noGrp="1"/>
+          </p:cNvSpPr>
+          <p:nvPr>
+            <p:ph idx="13" hasCustomPrompt="1"/>
+          </p:nvPr>
+        </p:nvSpPr>
+        <p:spPr>
+          <a:xfrm>
+            <a:off x="270000" y="943200"/>
+            <a:ext cx="11520000" cy="583200"/>
+          </a:xfrm>
+        </p:spPr>
+        <p:txBody>
+          <a:bodyPr wrap="none" lIns="0" tIns="0" rIns="0" bIns="0" anchor="ctr">
+            <a:noAutofit/>
+          </a:bodyPr>
+          <a:lstStyle>
+            <a:lvl1pPr marL="0" indent="0" algn="l">
+              <a:buFontTx/>
+              <a:buNone/>
+              <a:defRPr sz="1300" b="1">
+                <a:solidFill>
+                  <a:srgbClr val="333333"/>
+                </a:solidFill>
+                <a:latin typeface="맑은 고딕" panose="020B0503020000020004" pitchFamily="50" charset="-127"/>
+                <a:ea typeface="맑은 고딕" panose="020B0503020000020004" pitchFamily="50" charset="-127"/>
+              </a:defRPr>
+            </a:lvl1pPr>
+          </a:lstStyle>
+          <a:p>
+            <a:pPr lvl="0"/>
+            <a:r>
+              <a:rPr lang="ko-KR" altLang="en-US"/>
+              <a:t>■ 본문</a:t>
+            </a:r>
+          </a:p>
+        </p:txBody>
+      </p:sp>
       <p:cxnSp>
         <p:nvCxnSpPr>
-          <p:cNvPr id="6" name="DRB_Divider">
+          <p:cNvPr id="7" name="DRB_Divider">
             <a:extLst>
               <a:ext uri="{FF2B5EF4-FFF2-40B4-BE49-F238E27FC236}">
-                <a16:creationId xmlns:a16="http://schemas.microsoft.com/office/drawing/2014/main" id="{5C423C6B-BE15-4EE8-B26F-1A8F2401861F}"/>
+                <a16:creationId xmlns:a16="http://schemas.microsoft.com/office/drawing/2014/main" id="{8994E224-48C4-5F55-0E69-6911A9B2ECFD}"/>
               </a:ext>
             </a:extLst>
           </p:cNvPr>
@@ -2649,10 +2697,10 @@
       </p:cxnSp>
       <p:pic>
         <p:nvPicPr>
-          <p:cNvPr id="8" name="DRB_Samsung_Logo">
+          <p:cNvPr id="13" name="DRB_Samsung_Logo">
             <a:extLst>
               <a:ext uri="{FF2B5EF4-FFF2-40B4-BE49-F238E27FC236}">
-                <a16:creationId xmlns:a16="http://schemas.microsoft.com/office/drawing/2014/main" id="{D958198B-4F1F-0A9A-A41F-6FA05FC3CF66}"/>
+                <a16:creationId xmlns:a16="http://schemas.microsoft.com/office/drawing/2014/main" id="{D813056B-B96D-313D-2CA3-3532A24B6A25}"/>
               </a:ext>
             </a:extLst>
           </p:cNvPr>
@@ -2679,10 +2727,10 @@
       </p:pic>
       <p:sp>
         <p:nvSpPr>
-          <p:cNvPr id="9" name="DRB_Footer_Message">
+          <p:cNvPr id="14" name="DRB_Footer_Message">
             <a:extLst>
               <a:ext uri="{FF2B5EF4-FFF2-40B4-BE49-F238E27FC236}">
-                <a16:creationId xmlns:a16="http://schemas.microsoft.com/office/drawing/2014/main" id="{C90DABC8-4AD9-6A58-EC87-52C455740A0F}"/>
+                <a16:creationId xmlns:a16="http://schemas.microsoft.com/office/drawing/2014/main" id="{B538CEB9-354C-206E-BB99-FC9FE179AB47}"/>
               </a:ext>
             </a:extLst>
           </p:cNvPr>
@@ -2721,10 +2769,10 @@
       </p:sp>
       <p:sp>
         <p:nvSpPr>
-          <p:cNvPr id="10" name="DRB_Confidential">
+          <p:cNvPr id="15" name="DRB_Confidential">
             <a:extLst>
               <a:ext uri="{FF2B5EF4-FFF2-40B4-BE49-F238E27FC236}">
-                <a16:creationId xmlns:a16="http://schemas.microsoft.com/office/drawing/2014/main" id="{298B1028-FFE7-D7AF-BBA9-8B2607B45835}"/>
+                <a16:creationId xmlns:a16="http://schemas.microsoft.com/office/drawing/2014/main" id="{B4400CB8-75A8-2206-036E-92747DE04F4D}"/>
               </a:ext>
             </a:extLst>
           </p:cNvPr>
@@ -2765,54 +2813,6 @@
               <a:latin typeface="맑은 고딕" panose="020B0503020000020004" pitchFamily="50" charset="-127"/>
               <a:ea typeface="맑은 고딕" panose="020B0503020000020004" pitchFamily="50" charset="-127"/>
             </a:endParaRPr>
-          </a:p>
-        </p:txBody>
-      </p:sp>
-      <p:sp>
-        <p:nvSpPr>
-          <p:cNvPr id="11" name="DRB_Body_Placeholder">
-            <a:extLst>
-              <a:ext uri="{FF2B5EF4-FFF2-40B4-BE49-F238E27FC236}">
-                <a16:creationId xmlns:a16="http://schemas.microsoft.com/office/drawing/2014/main" id="{E155BF77-A51A-D56F-58EB-6AD12F6E2296}"/>
-              </a:ext>
-            </a:extLst>
-          </p:cNvPr>
-          <p:cNvSpPr>
-            <a:spLocks noGrp="1"/>
-          </p:cNvSpPr>
-          <p:nvPr>
-            <p:ph idx="13" hasCustomPrompt="1"/>
-          </p:nvPr>
-        </p:nvSpPr>
-        <p:spPr>
-          <a:xfrm>
-            <a:off x="270000" y="943200"/>
-            <a:ext cx="11520000" cy="583200"/>
-          </a:xfrm>
-        </p:spPr>
-        <p:txBody>
-          <a:bodyPr wrap="none" lIns="0" tIns="0" rIns="0" bIns="0" anchor="ctr">
-            <a:noAutofit/>
-          </a:bodyPr>
-          <a:lstStyle>
-            <a:lvl1pPr marL="0" indent="0" algn="l">
-              <a:buFontTx/>
-              <a:buNone/>
-              <a:defRPr sz="1300" b="1">
-                <a:solidFill>
-                  <a:srgbClr val="333333"/>
-                </a:solidFill>
-                <a:latin typeface="맑은 고딕" panose="020B0503020000020004" pitchFamily="50" charset="-127"/>
-                <a:ea typeface="맑은 고딕" panose="020B0503020000020004" pitchFamily="50" charset="-127"/>
-              </a:defRPr>
-            </a:lvl1pPr>
-          </a:lstStyle>
-          <a:p>
-            <a:pPr lvl="0"/>
-            <a:r>
-              <a:rPr lang="ko-KR" altLang="en-US"/>
-              <a:t>■ 본문</a:t>
-            </a:r>
           </a:p>
         </p:txBody>
       </p:sp>
@@ -3981,7 +3981,7 @@
           <p:cNvPr id="2" name="제목 1">
             <a:extLst>
               <a:ext uri="{FF2B5EF4-FFF2-40B4-BE49-F238E27FC236}">
-                <a16:creationId xmlns:a16="http://schemas.microsoft.com/office/drawing/2014/main" id="{A63DC396-DA84-3DE2-5DA2-24A9ABBD6DF5}"/>
+                <a16:creationId xmlns:a16="http://schemas.microsoft.com/office/drawing/2014/main" id="{556F7639-63CB-AB90-5905-9D1490C202F5}"/>
               </a:ext>
             </a:extLst>
           </p:cNvPr>
@@ -4010,7 +4010,7 @@
           <p:cNvPr id="3" name="내용 개체 틀 2">
             <a:extLst>
               <a:ext uri="{FF2B5EF4-FFF2-40B4-BE49-F238E27FC236}">
-                <a16:creationId xmlns:a16="http://schemas.microsoft.com/office/drawing/2014/main" id="{9EEF82D1-D092-C46D-C9A9-3C7E08FF1387}"/>
+                <a16:creationId xmlns:a16="http://schemas.microsoft.com/office/drawing/2014/main" id="{B9755D41-D955-5D5C-3361-71CE98D991A5}"/>
               </a:ext>
             </a:extLst>
           </p:cNvPr>
@@ -4045,7 +4045,7 @@
           <p:cNvPr id="4" name="DRB_Affiliation_Sample">
             <a:extLst>
               <a:ext uri="{FF2B5EF4-FFF2-40B4-BE49-F238E27FC236}">
-                <a16:creationId xmlns:a16="http://schemas.microsoft.com/office/drawing/2014/main" id="{8100EAB6-C37E-A01D-88D2-26A953BFFEF2}"/>
+                <a16:creationId xmlns:a16="http://schemas.microsoft.com/office/drawing/2014/main" id="{D5184702-2E57-6479-9B90-FEF0182929D3}"/>
               </a:ext>
             </a:extLst>
           </p:cNvPr>
@@ -4077,27 +4077,7 @@
                 <a:latin typeface="맑은 고딕" panose="020B0503020000020004" pitchFamily="50" charset="-127"/>
                 <a:ea typeface="맑은 고딕" panose="020B0503020000020004" pitchFamily="50" charset="-127"/>
               </a:rPr>
-              <a:t>Flash PE</a:t>
-            </a:r>
-            <a:r>
-              <a:rPr lang="ko-KR" altLang="en-US" sz="1200">
-                <a:solidFill>
-                  <a:srgbClr val="7F7F7F"/>
-                </a:solidFill>
-                <a:latin typeface="맑은 고딕" panose="020B0503020000020004" pitchFamily="50" charset="-127"/>
-                <a:ea typeface="맑은 고딕" panose="020B0503020000020004" pitchFamily="50" charset="-127"/>
-              </a:rPr>
-              <a:t>팀 </a:t>
-            </a:r>
-            <a:r>
-              <a:rPr lang="en-US" altLang="ko-KR" sz="1200">
-                <a:solidFill>
-                  <a:srgbClr val="7F7F7F"/>
-                </a:solidFill>
-                <a:latin typeface="맑은 고딕" panose="020B0503020000020004" pitchFamily="50" charset="-127"/>
-                <a:ea typeface="맑은 고딕" panose="020B0503020000020004" pitchFamily="50" charset="-127"/>
-              </a:rPr>
-              <a:t>/ </a:t>
+              <a:t>Flash PE / </a:t>
             </a:r>
             <a:r>
               <a:rPr lang="ko-KR" altLang="en-US" sz="1200">
@@ -4115,7 +4095,7 @@
     </p:spTree>
     <p:extLst>
       <p:ext uri="{BB962C8B-B14F-4D97-AF65-F5344CB8AC3E}">
-        <p14:creationId xmlns:p14="http://schemas.microsoft.com/office/powerpoint/2010/main" val="3927136239"/>
+        <p14:creationId xmlns:p14="http://schemas.microsoft.com/office/powerpoint/2010/main" val="3262089415"/>
       </p:ext>
     </p:extLst>
   </p:cSld>

</xml_diff>